<commit_message>
Improve poster text hierarchy and preflight
</commit_message>
<xml_diff>
--- a/examples/aurora-synthetic/output/default/aurora-synthetic-default-academic-safe.pptx
+++ b/examples/aurora-synthetic/output/default/aurora-synthetic-default-academic-safe.pptx
@@ -2,13 +2,13 @@
 <file path=ppt/presentation.xml><?xml version="1.0" encoding="utf-8"?>
 <p:presentation xmlns:p="http://schemas.openxmlformats.org/presentationml/2006/main">
   <p:sldMasterIdLst>
-    <p:sldMasterId xmlns:r="http://schemas.openxmlformats.org/officeDocument/2006/relationships" id="2147483648" r:id="R8015182b2d56403f"/>
+    <p:sldMasterId xmlns:r="http://schemas.openxmlformats.org/officeDocument/2006/relationships" id="2147483648" r:id="R7b18fe6d4c674490"/>
   </p:sldMasterIdLst>
   <p:notesMasterIdLst>
-    <p:notesMasterId xmlns:r="http://schemas.openxmlformats.org/officeDocument/2006/relationships" r:id="R2a4aa9a544e9453f"/>
+    <p:notesMasterId xmlns:r="http://schemas.openxmlformats.org/officeDocument/2006/relationships" r:id="R037c73c4cccd4ea3"/>
   </p:notesMasterIdLst>
   <p:sldIdLst>
-    <p:sldId xmlns:r="http://schemas.openxmlformats.org/officeDocument/2006/relationships" id="256" r:id="R350546b6c92444d1"/>
+    <p:sldId xmlns:r="http://schemas.openxmlformats.org/officeDocument/2006/relationships" id="256" r:id="R5c9386cfbcdd4d93"/>
   </p:sldIdLst>
   <p:sldSz cx="42805350" cy="30279975"/>
   <p:notesSz cx="6858000" cy="9144000"/>
@@ -530,7 +530,7 @@
   </p:cSld>
   <p:clrMap bg1="lt1" tx1="dk1" bg2="lt2" tx2="dk2" accent1="accent1" accent2="accent2" accent3="accent3" accent4="accent4" accent5="accent5" accent6="accent6" hlink="hlink" folHlink="folHlink"/>
   <p:sldLayoutIdLst>
-    <p:sldLayoutId xmlns:r="http://schemas.openxmlformats.org/officeDocument/2006/relationships" id="2147483649" r:id="Ra853d59fe46e4f57"/>
+    <p:sldLayoutId xmlns:r="http://schemas.openxmlformats.org/officeDocument/2006/relationships" id="2147483649" r:id="R30ea027aa9b54598"/>
   </p:sldLayoutIdLst>
   <p:txStyles>
     <p:titleStyle>
@@ -1078,10 +1078,10 @@
       </p:grpSpPr>
       <p:sp>
         <p:nvSpPr>
-          <p:cNvPr id="88" name="header-band">
-            <a:extLst xmlns:a="http://schemas.openxmlformats.org/drawingml/2006/main">
-              <a:ext uri="{FF2B5EF4-FFF2-40B4-BE49-F238E27FC236}">
-                <a16:creationId xmlns:a16="http://schemas.microsoft.com/office/drawing/2014/main" id="{76B97E08-92EB-41FB-AA2B-7171062A1ACA}"/>
+          <p:cNvPr id="90" name="header-band">
+            <a:extLst xmlns:a="http://schemas.openxmlformats.org/drawingml/2006/main">
+              <a:ext uri="{FF2B5EF4-FFF2-40B4-BE49-F238E27FC236}">
+                <a16:creationId xmlns:a16="http://schemas.microsoft.com/office/drawing/2014/main" id="{711B5F54-A6C8-4516-8460-DFE797A3751A}"/>
               </a:ext>
             </a:extLst>
           </p:cNvPr>
@@ -1114,7 +1114,7 @@
           <p:cNvPr id="2" name="top-accent">
             <a:extLst xmlns:a="http://schemas.openxmlformats.org/drawingml/2006/main">
               <a:ext uri="{FF2B5EF4-FFF2-40B4-BE49-F238E27FC236}">
-                <a16:creationId xmlns:a16="http://schemas.microsoft.com/office/drawing/2014/main" id="{73B22AB5-21C2-45FF-9827-F51BEACD7212}"/>
+                <a16:creationId xmlns:a16="http://schemas.microsoft.com/office/drawing/2014/main" id="{80E82011-A904-40D5-9670-008AA5977045}"/>
               </a:ext>
             </a:extLst>
           </p:cNvPr>
@@ -1147,7 +1147,7 @@
           <p:cNvPr id="3" name="poster-title">
             <a:extLst xmlns:a="http://schemas.openxmlformats.org/drawingml/2006/main">
               <a:ext uri="{FF2B5EF4-FFF2-40B4-BE49-F238E27FC236}">
-                <a16:creationId xmlns:a16="http://schemas.microsoft.com/office/drawing/2014/main" id="{AE35A472-CF5D-489E-8641-1E8DCC14DC0A}"/>
+                <a16:creationId xmlns:a16="http://schemas.microsoft.com/office/drawing/2014/main" id="{C9030267-55CF-450F-852B-5D0F474B8A6A}"/>
               </a:ext>
             </a:extLst>
           </p:cNvPr>
@@ -1214,7 +1214,7 @@
           <p:cNvPr id="4" name="authors">
             <a:extLst xmlns:a="http://schemas.openxmlformats.org/drawingml/2006/main">
               <a:ext uri="{FF2B5EF4-FFF2-40B4-BE49-F238E27FC236}">
-                <a16:creationId xmlns:a16="http://schemas.microsoft.com/office/drawing/2014/main" id="{197AC713-115E-40B9-9536-8C08C5D2C2AB}"/>
+                <a16:creationId xmlns:a16="http://schemas.microsoft.com/office/drawing/2014/main" id="{68105D84-F0AE-4BF0-9601-288B9A47C1F0}"/>
               </a:ext>
             </a:extLst>
           </p:cNvPr>
@@ -1264,7 +1264,7 @@
           <p:cNvPr id="5" name="affiliations">
             <a:extLst xmlns:a="http://schemas.openxmlformats.org/drawingml/2006/main">
               <a:ext uri="{FF2B5EF4-FFF2-40B4-BE49-F238E27FC236}">
-                <a16:creationId xmlns:a16="http://schemas.microsoft.com/office/drawing/2014/main" id="{62012248-12D2-42AB-9C40-8045ABD23018}"/>
+                <a16:creationId xmlns:a16="http://schemas.microsoft.com/office/drawing/2014/main" id="{0CCDEE52-EF52-4973-A021-4D70A9DD1E62}"/>
               </a:ext>
             </a:extLst>
           </p:cNvPr>
@@ -1314,7 +1314,7 @@
           <p:cNvPr id="6" name="citation">
             <a:extLst xmlns:a="http://schemas.openxmlformats.org/drawingml/2006/main">
               <a:ext uri="{FF2B5EF4-FFF2-40B4-BE49-F238E27FC236}">
-                <a16:creationId xmlns:a16="http://schemas.microsoft.com/office/drawing/2014/main" id="{DED63E32-D2F7-4EA3-A9D2-211830D292D0}"/>
+                <a16:creationId xmlns:a16="http://schemas.microsoft.com/office/drawing/2014/main" id="{D48AD543-BE79-4769-9396-0665D27D22E1}"/>
               </a:ext>
             </a:extLst>
           </p:cNvPr>
@@ -1364,7 +1364,7 @@
           <p:cNvPr id="7" name="logo-slot-fictional-lab-logo">
             <a:extLst xmlns:a="http://schemas.openxmlformats.org/drawingml/2006/main">
               <a:ext uri="{FF2B5EF4-FFF2-40B4-BE49-F238E27FC236}">
-                <a16:creationId xmlns:a16="http://schemas.microsoft.com/office/drawing/2014/main" id="{0421F854-35D7-4FF2-B33B-C5EA8F89831B}"/>
+                <a16:creationId xmlns:a16="http://schemas.microsoft.com/office/drawing/2014/main" id="{9769743B-2D73-4296-B3AA-95CA4BFACF75}"/>
               </a:ext>
             </a:extLst>
           </p:cNvPr>
@@ -1399,7 +1399,7 @@
           <p:cNvPr id="8" name="logo-placeholder-fictional-lab-logo">
             <a:extLst xmlns:a="http://schemas.openxmlformats.org/drawingml/2006/main">
               <a:ext uri="{FF2B5EF4-FFF2-40B4-BE49-F238E27FC236}">
-                <a16:creationId xmlns:a16="http://schemas.microsoft.com/office/drawing/2014/main" id="{0AC69709-D18E-4A1A-9B8C-66856EA23EC6}"/>
+                <a16:creationId xmlns:a16="http://schemas.microsoft.com/office/drawing/2014/main" id="{B125F909-0CE9-4472-9CD7-73C636F2C28C}"/>
               </a:ext>
             </a:extLst>
           </p:cNvPr>
@@ -1449,7 +1449,7 @@
           <p:cNvPr id="9" name="header-summary">
             <a:extLst xmlns:a="http://schemas.openxmlformats.org/drawingml/2006/main">
               <a:ext uri="{FF2B5EF4-FFF2-40B4-BE49-F238E27FC236}">
-                <a16:creationId xmlns:a16="http://schemas.microsoft.com/office/drawing/2014/main" id="{51E15929-634D-4576-B92D-7C60B21295CE}"/>
+                <a16:creationId xmlns:a16="http://schemas.microsoft.com/office/drawing/2014/main" id="{F0EFDFFD-E510-483B-B92E-7B5C3D13B064}"/>
               </a:ext>
             </a:extLst>
           </p:cNvPr>
@@ -1482,7 +1482,7 @@
           <p:cNvPr id="10" name="header-metric-1-value">
             <a:extLst xmlns:a="http://schemas.openxmlformats.org/drawingml/2006/main">
               <a:ext uri="{FF2B5EF4-FFF2-40B4-BE49-F238E27FC236}">
-                <a16:creationId xmlns:a16="http://schemas.microsoft.com/office/drawing/2014/main" id="{44087AA6-C940-4F6D-AD60-4C6D0E51C256}"/>
+                <a16:creationId xmlns:a16="http://schemas.microsoft.com/office/drawing/2014/main" id="{C10ABB60-817D-49C9-A153-D73963F39432}"/>
               </a:ext>
             </a:extLst>
           </p:cNvPr>
@@ -1532,18 +1532,18 @@
           <p:cNvPr id="11" name="header-metric-1-label">
             <a:extLst xmlns:a="http://schemas.openxmlformats.org/drawingml/2006/main">
               <a:ext uri="{FF2B5EF4-FFF2-40B4-BE49-F238E27FC236}">
-                <a16:creationId xmlns:a16="http://schemas.microsoft.com/office/drawing/2014/main" id="{BDA31662-DD71-40EB-A750-D1B8DB7219D0}"/>
-              </a:ext>
-            </a:extLst>
-          </p:cNvPr>
-          <p:cNvSpPr>
-            <a:spLocks xmlns:a="http://schemas.openxmlformats.org/drawingml/2006/main" noGrp="1"/>
-          </p:cNvSpPr>
-          <p:nvPr/>
-        </p:nvSpPr>
-        <p:spPr>
-          <a:xfrm xmlns:a="http://schemas.openxmlformats.org/drawingml/2006/main">
-            <a:off x="32766000" y="3067050"/>
+                <a16:creationId xmlns:a16="http://schemas.microsoft.com/office/drawing/2014/main" id="{425348D2-896E-4BE9-9109-05E3B6A8E213}"/>
+              </a:ext>
+            </a:extLst>
+          </p:cNvPr>
+          <p:cNvSpPr>
+            <a:spLocks xmlns:a="http://schemas.openxmlformats.org/drawingml/2006/main" noGrp="1"/>
+          </p:cNvSpPr>
+          <p:nvPr/>
+        </p:nvSpPr>
+        <p:spPr>
+          <a:xfrm xmlns:a="http://schemas.openxmlformats.org/drawingml/2006/main">
+            <a:off x="32766000" y="3028950"/>
             <a:ext cx="2476500" cy="838200"/>
           </a:xfrm>
           <a:prstGeom xmlns:a="http://schemas.openxmlformats.org/drawingml/2006/main" prst="rect">
@@ -1582,7 +1582,7 @@
           <p:cNvPr id="12" name="header-metric-2-value">
             <a:extLst xmlns:a="http://schemas.openxmlformats.org/drawingml/2006/main">
               <a:ext uri="{FF2B5EF4-FFF2-40B4-BE49-F238E27FC236}">
-                <a16:creationId xmlns:a16="http://schemas.microsoft.com/office/drawing/2014/main" id="{191FBCD7-760B-4E2D-8170-DB5C408FDDB9}"/>
+                <a16:creationId xmlns:a16="http://schemas.microsoft.com/office/drawing/2014/main" id="{B1A82675-FF6D-4E9B-A863-9C5A64C9E39D}"/>
               </a:ext>
             </a:extLst>
           </p:cNvPr>
@@ -1632,18 +1632,18 @@
           <p:cNvPr id="13" name="header-metric-2-label">
             <a:extLst xmlns:a="http://schemas.openxmlformats.org/drawingml/2006/main">
               <a:ext uri="{FF2B5EF4-FFF2-40B4-BE49-F238E27FC236}">
-                <a16:creationId xmlns:a16="http://schemas.microsoft.com/office/drawing/2014/main" id="{D14905DC-1088-4847-9269-44027086AB6D}"/>
-              </a:ext>
-            </a:extLst>
-          </p:cNvPr>
-          <p:cNvSpPr>
-            <a:spLocks xmlns:a="http://schemas.openxmlformats.org/drawingml/2006/main" noGrp="1"/>
-          </p:cNvSpPr>
-          <p:nvPr/>
-        </p:nvSpPr>
-        <p:spPr>
-          <a:xfrm xmlns:a="http://schemas.openxmlformats.org/drawingml/2006/main">
-            <a:off x="35623500" y="3067050"/>
+                <a16:creationId xmlns:a16="http://schemas.microsoft.com/office/drawing/2014/main" id="{F3EB720E-DED7-4EC7-84AB-C8DD1BD28562}"/>
+              </a:ext>
+            </a:extLst>
+          </p:cNvPr>
+          <p:cNvSpPr>
+            <a:spLocks xmlns:a="http://schemas.openxmlformats.org/drawingml/2006/main" noGrp="1"/>
+          </p:cNvSpPr>
+          <p:nvPr/>
+        </p:nvSpPr>
+        <p:spPr>
+          <a:xfrm xmlns:a="http://schemas.openxmlformats.org/drawingml/2006/main">
+            <a:off x="35623500" y="3028950"/>
             <a:ext cx="2476500" cy="838200"/>
           </a:xfrm>
           <a:prstGeom xmlns:a="http://schemas.openxmlformats.org/drawingml/2006/main" prst="rect">
@@ -1682,7 +1682,7 @@
           <p:cNvPr id="14" name="header-metric-3-value">
             <a:extLst xmlns:a="http://schemas.openxmlformats.org/drawingml/2006/main">
               <a:ext uri="{FF2B5EF4-FFF2-40B4-BE49-F238E27FC236}">
-                <a16:creationId xmlns:a16="http://schemas.microsoft.com/office/drawing/2014/main" id="{9943FA08-8DC9-49FA-8B5E-814BF706C2D4}"/>
+                <a16:creationId xmlns:a16="http://schemas.microsoft.com/office/drawing/2014/main" id="{56803559-CA57-4E47-B07F-80514B990FE3}"/>
               </a:ext>
             </a:extLst>
           </p:cNvPr>
@@ -1732,18 +1732,18 @@
           <p:cNvPr id="15" name="header-metric-3-label">
             <a:extLst xmlns:a="http://schemas.openxmlformats.org/drawingml/2006/main">
               <a:ext uri="{FF2B5EF4-FFF2-40B4-BE49-F238E27FC236}">
-                <a16:creationId xmlns:a16="http://schemas.microsoft.com/office/drawing/2014/main" id="{A2CD411B-91F2-4D01-BCF5-B55EC8B6A9E6}"/>
-              </a:ext>
-            </a:extLst>
-          </p:cNvPr>
-          <p:cNvSpPr>
-            <a:spLocks xmlns:a="http://schemas.openxmlformats.org/drawingml/2006/main" noGrp="1"/>
-          </p:cNvSpPr>
-          <p:nvPr/>
-        </p:nvSpPr>
-        <p:spPr>
-          <a:xfrm xmlns:a="http://schemas.openxmlformats.org/drawingml/2006/main">
-            <a:off x="38481000" y="3067050"/>
+                <a16:creationId xmlns:a16="http://schemas.microsoft.com/office/drawing/2014/main" id="{21D180BA-C0DB-46B3-AEEB-C662711B7CA0}"/>
+              </a:ext>
+            </a:extLst>
+          </p:cNvPr>
+          <p:cNvSpPr>
+            <a:spLocks xmlns:a="http://schemas.openxmlformats.org/drawingml/2006/main" noGrp="1"/>
+          </p:cNvSpPr>
+          <p:nvPr/>
+        </p:nvSpPr>
+        <p:spPr>
+          <a:xfrm xmlns:a="http://schemas.openxmlformats.org/drawingml/2006/main">
+            <a:off x="38481000" y="3028950"/>
             <a:ext cx="2476500" cy="838200"/>
           </a:xfrm>
           <a:prstGeom xmlns:a="http://schemas.openxmlformats.org/drawingml/2006/main" prst="rect">
@@ -1782,7 +1782,7 @@
           <p:cNvPr id="16" name="question-title">
             <a:extLst xmlns:a="http://schemas.openxmlformats.org/drawingml/2006/main">
               <a:ext uri="{FF2B5EF4-FFF2-40B4-BE49-F238E27FC236}">
-                <a16:creationId xmlns:a16="http://schemas.microsoft.com/office/drawing/2014/main" id="{64B6A1F8-DED8-4ED5-BFEA-827B0FCC2493}"/>
+                <a16:creationId xmlns:a16="http://schemas.microsoft.com/office/drawing/2014/main" id="{3E14165F-C537-4C53-8333-6F0AE67BBE24}"/>
               </a:ext>
             </a:extLst>
           </p:cNvPr>
@@ -1832,7 +1832,7 @@
           <p:cNvPr id="17" name="question-rule">
             <a:extLst xmlns:a="http://schemas.openxmlformats.org/drawingml/2006/main">
               <a:ext uri="{FF2B5EF4-FFF2-40B4-BE49-F238E27FC236}">
-                <a16:creationId xmlns:a16="http://schemas.microsoft.com/office/drawing/2014/main" id="{35A2BC68-676F-4EE0-8C46-509F5DDAFD9D}"/>
+                <a16:creationId xmlns:a16="http://schemas.microsoft.com/office/drawing/2014/main" id="{816704D9-9E9A-46BF-84E6-F77044FF3FDB}"/>
               </a:ext>
             </a:extLst>
           </p:cNvPr>
@@ -1865,7 +1865,7 @@
           <p:cNvPr id="18" name="research-question">
             <a:extLst xmlns:a="http://schemas.openxmlformats.org/drawingml/2006/main">
               <a:ext uri="{FF2B5EF4-FFF2-40B4-BE49-F238E27FC236}">
-                <a16:creationId xmlns:a16="http://schemas.microsoft.com/office/drawing/2014/main" id="{CBD0F0F7-74ED-4F89-ADE3-5558835654C5}"/>
+                <a16:creationId xmlns:a16="http://schemas.microsoft.com/office/drawing/2014/main" id="{030CF96F-7515-4CA0-BBA0-07F283A5D355}"/>
               </a:ext>
             </a:extLst>
           </p:cNvPr>
@@ -1877,7 +1877,7 @@
         <p:spPr>
           <a:xfrm xmlns:a="http://schemas.openxmlformats.org/drawingml/2006/main">
             <a:off x="1333500" y="6496050"/>
-            <a:ext cx="11620500" cy="2238375"/>
+            <a:ext cx="11620500" cy="2095500"/>
           </a:xfrm>
           <a:prstGeom xmlns:a="http://schemas.openxmlformats.org/drawingml/2006/main" prst="rect">
             <a:avLst/>
@@ -1915,7 +1915,7 @@
           <p:cNvPr id="19" name="question-evidence">
             <a:extLst xmlns:a="http://schemas.openxmlformats.org/drawingml/2006/main">
               <a:ext uri="{FF2B5EF4-FFF2-40B4-BE49-F238E27FC236}">
-                <a16:creationId xmlns:a16="http://schemas.microsoft.com/office/drawing/2014/main" id="{5EB60026-8E3A-4157-A1FF-7B2A882CC0AB}"/>
+                <a16:creationId xmlns:a16="http://schemas.microsoft.com/office/drawing/2014/main" id="{47BA5A9E-4032-49FB-B2D0-3DE5EECC2D5F}"/>
               </a:ext>
             </a:extLst>
           </p:cNvPr>
@@ -1943,14 +1943,14 @@
           <a:lstStyle xmlns:a="http://schemas.openxmlformats.org/drawingml/2006/main"/>
           <a:p xmlns:a="http://schemas.openxmlformats.org/drawingml/2006/main">
             <a:pPr>
-              <a:defRPr sz="1875" i="1">
+              <a:defRPr sz="1875">
                 <a:solidFill>
                   <a:srgbClr val="2C8C99"/>
                 </a:solidFill>
               </a:defRPr>
             </a:pPr>
             <a:r>
-              <a:rPr sz="1875" i="1">
+              <a:rPr sz="1875">
                 <a:solidFill>
                   <a:srgbClr val="2C8C99"/>
                 </a:solidFill>
@@ -1965,7 +1965,7 @@
           <p:cNvPr id="20" name="pipeline-title">
             <a:extLst xmlns:a="http://schemas.openxmlformats.org/drawingml/2006/main">
               <a:ext uri="{FF2B5EF4-FFF2-40B4-BE49-F238E27FC236}">
-                <a16:creationId xmlns:a16="http://schemas.microsoft.com/office/drawing/2014/main" id="{35BE22B3-B8BE-48ED-B7AD-55825C436DE5}"/>
+                <a16:creationId xmlns:a16="http://schemas.microsoft.com/office/drawing/2014/main" id="{E191E3E6-F947-4CAB-B5B8-9371C0FF59FD}"/>
               </a:ext>
             </a:extLst>
           </p:cNvPr>
@@ -2015,7 +2015,7 @@
           <p:cNvPr id="21" name="pipeline-rule">
             <a:extLst xmlns:a="http://schemas.openxmlformats.org/drawingml/2006/main">
               <a:ext uri="{FF2B5EF4-FFF2-40B4-BE49-F238E27FC236}">
-                <a16:creationId xmlns:a16="http://schemas.microsoft.com/office/drawing/2014/main" id="{8D2B7ADE-470B-42DC-B6E1-1BD4956DCA87}"/>
+                <a16:creationId xmlns:a16="http://schemas.microsoft.com/office/drawing/2014/main" id="{E45799C4-E5B2-4F00-84C2-4F9B24D0490C}"/>
               </a:ext>
             </a:extLst>
           </p:cNvPr>
@@ -2048,7 +2048,7 @@
           <p:cNvPr id="22" name="pipeline-1-number-bg">
             <a:extLst xmlns:a="http://schemas.openxmlformats.org/drawingml/2006/main">
               <a:ext uri="{FF2B5EF4-FFF2-40B4-BE49-F238E27FC236}">
-                <a16:creationId xmlns:a16="http://schemas.microsoft.com/office/drawing/2014/main" id="{8C088A21-097F-46EF-88B6-B51AF039BDF0}"/>
+                <a16:creationId xmlns:a16="http://schemas.microsoft.com/office/drawing/2014/main" id="{931D1997-9959-4617-9F55-65765DB45407}"/>
               </a:ext>
             </a:extLst>
           </p:cNvPr>
@@ -2081,7 +2081,7 @@
           <p:cNvPr id="23" name="pipeline-1-number">
             <a:extLst xmlns:a="http://schemas.openxmlformats.org/drawingml/2006/main">
               <a:ext uri="{FF2B5EF4-FFF2-40B4-BE49-F238E27FC236}">
-                <a16:creationId xmlns:a16="http://schemas.microsoft.com/office/drawing/2014/main" id="{6FE64AD5-FF93-46D0-BDBD-EB88C0B9B29A}"/>
+                <a16:creationId xmlns:a16="http://schemas.microsoft.com/office/drawing/2014/main" id="{767453B4-7147-491B-B297-6D4550EFF658}"/>
               </a:ext>
             </a:extLst>
           </p:cNvPr>
@@ -2131,7 +2131,7 @@
           <p:cNvPr id="24" name="pipeline-1-text">
             <a:extLst xmlns:a="http://schemas.openxmlformats.org/drawingml/2006/main">
               <a:ext uri="{FF2B5EF4-FFF2-40B4-BE49-F238E27FC236}">
-                <a16:creationId xmlns:a16="http://schemas.microsoft.com/office/drawing/2014/main" id="{E3AB6F50-6967-45D5-9B9E-E7BB9152DF0A}"/>
+                <a16:creationId xmlns:a16="http://schemas.microsoft.com/office/drawing/2014/main" id="{1C5FC521-62CE-4603-B0D7-E673CFA30617}"/>
               </a:ext>
             </a:extLst>
           </p:cNvPr>
@@ -2159,14 +2159,14 @@
           <a:lstStyle xmlns:a="http://schemas.openxmlformats.org/drawingml/2006/main"/>
           <a:p xmlns:a="http://schemas.openxmlformats.org/drawingml/2006/main">
             <a:pPr>
-              <a:defRPr sz="2850" b="1">
-                <a:solidFill>
-                  <a:srgbClr val="102A43"/>
-                </a:solidFill>
-              </a:defRPr>
-            </a:pPr>
-            <a:r>
-              <a:rPr sz="2850" b="1">
+              <a:defRPr sz="2850">
+                <a:solidFill>
+                  <a:srgbClr val="102A43"/>
+                </a:solidFill>
+              </a:defRPr>
+            </a:pPr>
+            <a:r>
+              <a:rPr sz="2850">
                 <a:solidFill>
                   <a:srgbClr val="102A43"/>
                 </a:solidFill>
@@ -2181,7 +2181,7 @@
           <p:cNvPr id="25" name="pipeline-2-number-bg">
             <a:extLst xmlns:a="http://schemas.openxmlformats.org/drawingml/2006/main">
               <a:ext uri="{FF2B5EF4-FFF2-40B4-BE49-F238E27FC236}">
-                <a16:creationId xmlns:a16="http://schemas.microsoft.com/office/drawing/2014/main" id="{6E7C6F99-3D03-491E-BD51-4E2B9E60458B}"/>
+                <a16:creationId xmlns:a16="http://schemas.microsoft.com/office/drawing/2014/main" id="{3A6EC0B5-C36D-464E-BDB6-75567FB4C4D0}"/>
               </a:ext>
             </a:extLst>
           </p:cNvPr>
@@ -2214,7 +2214,7 @@
           <p:cNvPr id="26" name="pipeline-2-number">
             <a:extLst xmlns:a="http://schemas.openxmlformats.org/drawingml/2006/main">
               <a:ext uri="{FF2B5EF4-FFF2-40B4-BE49-F238E27FC236}">
-                <a16:creationId xmlns:a16="http://schemas.microsoft.com/office/drawing/2014/main" id="{B81108F7-EDF4-4684-A3C9-E453050F3087}"/>
+                <a16:creationId xmlns:a16="http://schemas.microsoft.com/office/drawing/2014/main" id="{3DCD41F6-BFE1-43A6-ACE6-9A244366AEF4}"/>
               </a:ext>
             </a:extLst>
           </p:cNvPr>
@@ -2264,7 +2264,7 @@
           <p:cNvPr id="27" name="pipeline-2-text">
             <a:extLst xmlns:a="http://schemas.openxmlformats.org/drawingml/2006/main">
               <a:ext uri="{FF2B5EF4-FFF2-40B4-BE49-F238E27FC236}">
-                <a16:creationId xmlns:a16="http://schemas.microsoft.com/office/drawing/2014/main" id="{925D2426-E48D-40C4-A77B-6AB78F253882}"/>
+                <a16:creationId xmlns:a16="http://schemas.microsoft.com/office/drawing/2014/main" id="{0EE55B41-3444-4B7C-8B93-0DEC89182795}"/>
               </a:ext>
             </a:extLst>
           </p:cNvPr>
@@ -2292,14 +2292,14 @@
           <a:lstStyle xmlns:a="http://schemas.openxmlformats.org/drawingml/2006/main"/>
           <a:p xmlns:a="http://schemas.openxmlformats.org/drawingml/2006/main">
             <a:pPr>
-              <a:defRPr sz="2850" b="1">
-                <a:solidFill>
-                  <a:srgbClr val="102A43"/>
-                </a:solidFill>
-              </a:defRPr>
-            </a:pPr>
-            <a:r>
-              <a:rPr sz="2850" b="1">
+              <a:defRPr sz="2850">
+                <a:solidFill>
+                  <a:srgbClr val="102A43"/>
+                </a:solidFill>
+              </a:defRPr>
+            </a:pPr>
+            <a:r>
+              <a:rPr sz="2850">
                 <a:solidFill>
                   <a:srgbClr val="102A43"/>
                 </a:solidFill>
@@ -2314,7 +2314,7 @@
           <p:cNvPr id="28" name="pipeline-3-number-bg">
             <a:extLst xmlns:a="http://schemas.openxmlformats.org/drawingml/2006/main">
               <a:ext uri="{FF2B5EF4-FFF2-40B4-BE49-F238E27FC236}">
-                <a16:creationId xmlns:a16="http://schemas.microsoft.com/office/drawing/2014/main" id="{A231EDDD-5B44-4EF1-BCD0-BC041CC1D065}"/>
+                <a16:creationId xmlns:a16="http://schemas.microsoft.com/office/drawing/2014/main" id="{9738DD88-ABA8-4698-BB37-7DA7EFCFBE04}"/>
               </a:ext>
             </a:extLst>
           </p:cNvPr>
@@ -2347,7 +2347,7 @@
           <p:cNvPr id="29" name="pipeline-3-number">
             <a:extLst xmlns:a="http://schemas.openxmlformats.org/drawingml/2006/main">
               <a:ext uri="{FF2B5EF4-FFF2-40B4-BE49-F238E27FC236}">
-                <a16:creationId xmlns:a16="http://schemas.microsoft.com/office/drawing/2014/main" id="{B72E8249-8FD5-493D-8707-491405C8FFB3}"/>
+                <a16:creationId xmlns:a16="http://schemas.microsoft.com/office/drawing/2014/main" id="{560D029C-EC9F-4F86-90A3-07CFFAFEEA36}"/>
               </a:ext>
             </a:extLst>
           </p:cNvPr>
@@ -2397,7 +2397,7 @@
           <p:cNvPr id="30" name="pipeline-3-text">
             <a:extLst xmlns:a="http://schemas.openxmlformats.org/drawingml/2006/main">
               <a:ext uri="{FF2B5EF4-FFF2-40B4-BE49-F238E27FC236}">
-                <a16:creationId xmlns:a16="http://schemas.microsoft.com/office/drawing/2014/main" id="{457C0282-C1FC-4C64-A67A-EEBE5083FCB3}"/>
+                <a16:creationId xmlns:a16="http://schemas.microsoft.com/office/drawing/2014/main" id="{8C5908B0-9E7B-4B68-9800-17881988E61C}"/>
               </a:ext>
             </a:extLst>
           </p:cNvPr>
@@ -2425,14 +2425,14 @@
           <a:lstStyle xmlns:a="http://schemas.openxmlformats.org/drawingml/2006/main"/>
           <a:p xmlns:a="http://schemas.openxmlformats.org/drawingml/2006/main">
             <a:pPr>
-              <a:defRPr sz="2850" b="1">
-                <a:solidFill>
-                  <a:srgbClr val="102A43"/>
-                </a:solidFill>
-              </a:defRPr>
-            </a:pPr>
-            <a:r>
-              <a:rPr sz="2850" b="1">
+              <a:defRPr sz="2850">
+                <a:solidFill>
+                  <a:srgbClr val="102A43"/>
+                </a:solidFill>
+              </a:defRPr>
+            </a:pPr>
+            <a:r>
+              <a:rPr sz="2850">
                 <a:solidFill>
                   <a:srgbClr val="102A43"/>
                 </a:solidFill>
@@ -2447,7 +2447,7 @@
           <p:cNvPr id="31" name="pipeline-4-number-bg">
             <a:extLst xmlns:a="http://schemas.openxmlformats.org/drawingml/2006/main">
               <a:ext uri="{FF2B5EF4-FFF2-40B4-BE49-F238E27FC236}">
-                <a16:creationId xmlns:a16="http://schemas.microsoft.com/office/drawing/2014/main" id="{19FDAD0D-1749-4714-BB85-C4B5E909D010}"/>
+                <a16:creationId xmlns:a16="http://schemas.microsoft.com/office/drawing/2014/main" id="{CC265BA4-C7D6-472E-9132-F69D54E472D1}"/>
               </a:ext>
             </a:extLst>
           </p:cNvPr>
@@ -2480,7 +2480,7 @@
           <p:cNvPr id="32" name="pipeline-4-number">
             <a:extLst xmlns:a="http://schemas.openxmlformats.org/drawingml/2006/main">
               <a:ext uri="{FF2B5EF4-FFF2-40B4-BE49-F238E27FC236}">
-                <a16:creationId xmlns:a16="http://schemas.microsoft.com/office/drawing/2014/main" id="{307E0CEC-F8B9-471F-8921-142B311CE6DC}"/>
+                <a16:creationId xmlns:a16="http://schemas.microsoft.com/office/drawing/2014/main" id="{A0FD30CE-295F-48FB-AEEE-CF33D0C7D6CB}"/>
               </a:ext>
             </a:extLst>
           </p:cNvPr>
@@ -2530,7 +2530,7 @@
           <p:cNvPr id="33" name="pipeline-4-text">
             <a:extLst xmlns:a="http://schemas.openxmlformats.org/drawingml/2006/main">
               <a:ext uri="{FF2B5EF4-FFF2-40B4-BE49-F238E27FC236}">
-                <a16:creationId xmlns:a16="http://schemas.microsoft.com/office/drawing/2014/main" id="{99F02AF8-2A70-482C-A606-1BDB9B46B543}"/>
+                <a16:creationId xmlns:a16="http://schemas.microsoft.com/office/drawing/2014/main" id="{1E10DFFB-9684-4277-8C5B-5F9129F5C4C4}"/>
               </a:ext>
             </a:extLst>
           </p:cNvPr>
@@ -2558,14 +2558,14 @@
           <a:lstStyle xmlns:a="http://schemas.openxmlformats.org/drawingml/2006/main"/>
           <a:p xmlns:a="http://schemas.openxmlformats.org/drawingml/2006/main">
             <a:pPr>
-              <a:defRPr sz="2850" b="1">
-                <a:solidFill>
-                  <a:srgbClr val="102A43"/>
-                </a:solidFill>
-              </a:defRPr>
-            </a:pPr>
-            <a:r>
-              <a:rPr sz="2850" b="1">
+              <a:defRPr sz="2850">
+                <a:solidFill>
+                  <a:srgbClr val="102A43"/>
+                </a:solidFill>
+              </a:defRPr>
+            </a:pPr>
+            <a:r>
+              <a:rPr sz="2850">
                 <a:solidFill>
                   <a:srgbClr val="102A43"/>
                 </a:solidFill>
@@ -2580,7 +2580,7 @@
           <p:cNvPr id="34" name="dataset-panel">
             <a:extLst xmlns:a="http://schemas.openxmlformats.org/drawingml/2006/main">
               <a:ext uri="{FF2B5EF4-FFF2-40B4-BE49-F238E27FC236}">
-                <a16:creationId xmlns:a16="http://schemas.microsoft.com/office/drawing/2014/main" id="{3DF89B08-8909-4C4B-9776-90A2F3AB4812}"/>
+                <a16:creationId xmlns:a16="http://schemas.microsoft.com/office/drawing/2014/main" id="{8646CAD6-2497-411B-9849-22B4ECFF8FB0}"/>
               </a:ext>
             </a:extLst>
           </p:cNvPr>
@@ -2615,7 +2615,7 @@
           <p:cNvPr id="35" name="dataset-kicker">
             <a:extLst xmlns:a="http://schemas.openxmlformats.org/drawingml/2006/main">
               <a:ext uri="{FF2B5EF4-FFF2-40B4-BE49-F238E27FC236}">
-                <a16:creationId xmlns:a16="http://schemas.microsoft.com/office/drawing/2014/main" id="{DCA02CDE-35A1-44A3-ABD1-4AED6029D061}"/>
+                <a16:creationId xmlns:a16="http://schemas.microsoft.com/office/drawing/2014/main" id="{83F91766-855B-4429-8B49-0F097FF9B1ED}"/>
               </a:ext>
             </a:extLst>
           </p:cNvPr>
@@ -2662,10 +2662,10 @@
       </p:sp>
       <p:sp>
         <p:nvSpPr>
-          <p:cNvPr id="36" name="datasets">
-            <a:extLst xmlns:a="http://schemas.openxmlformats.org/drawingml/2006/main">
-              <a:ext uri="{FF2B5EF4-FFF2-40B4-BE49-F238E27FC236}">
-                <a16:creationId xmlns:a16="http://schemas.microsoft.com/office/drawing/2014/main" id="{3B8F40FD-E399-4067-9D73-41275F095A68}"/>
+          <p:cNvPr id="36" name="dataset-lead">
+            <a:extLst xmlns:a="http://schemas.openxmlformats.org/drawingml/2006/main">
+              <a:ext uri="{FF2B5EF4-FFF2-40B4-BE49-F238E27FC236}">
+                <a16:creationId xmlns:a16="http://schemas.microsoft.com/office/drawing/2014/main" id="{F51F4B78-9B6E-4361-9F16-582394C69CED}"/>
               </a:ext>
             </a:extLst>
           </p:cNvPr>
@@ -2677,7 +2677,57 @@
         <p:spPr>
           <a:xfrm xmlns:a="http://schemas.openxmlformats.org/drawingml/2006/main">
             <a:off x="1600200" y="14239875"/>
-            <a:ext cx="11087100" cy="2190750"/>
+            <a:ext cx="11087100" cy="514350"/>
+          </a:xfrm>
+          <a:prstGeom xmlns:a="http://schemas.openxmlformats.org/drawingml/2006/main" prst="rect">
+            <a:avLst/>
+          </a:prstGeom>
+          <a:noFill xmlns:a="http://schemas.openxmlformats.org/drawingml/2006/main"/>
+          <a:ln xmlns:a="http://schemas.openxmlformats.org/drawingml/2006/main" w="0">
+            <a:noFill/>
+            <a:prstDash val="solid"/>
+          </a:ln>
+        </p:spPr>
+        <p:txBody>
+          <a:bodyPr xmlns:a="http://schemas.openxmlformats.org/drawingml/2006/main"/>
+          <a:lstStyle xmlns:a="http://schemas.openxmlformats.org/drawingml/2006/main"/>
+          <a:p xmlns:a="http://schemas.openxmlformats.org/drawingml/2006/main">
+            <a:pPr>
+              <a:defRPr sz="2850" b="1">
+                <a:solidFill>
+                  <a:srgbClr val="102A43"/>
+                </a:solidFill>
+              </a:defRPr>
+            </a:pPr>
+            <a:r>
+              <a:rPr sz="2850" b="1">
+                <a:solidFill>
+                  <a:srgbClr val="102A43"/>
+                </a:solidFill>
+              </a:rPr>
+              <a:t>Four deterministic synthetic cohorts</a:t>
+            </a:r>
+          </a:p>
+        </p:txBody>
+      </p:sp>
+      <p:sp>
+        <p:nvSpPr>
+          <p:cNvPr id="37" name="datasets">
+            <a:extLst xmlns:a="http://schemas.openxmlformats.org/drawingml/2006/main">
+              <a:ext uri="{FF2B5EF4-FFF2-40B4-BE49-F238E27FC236}">
+                <a16:creationId xmlns:a16="http://schemas.microsoft.com/office/drawing/2014/main" id="{0279D87B-90DE-4E9C-8D56-4AC732B9F306}"/>
+              </a:ext>
+            </a:extLst>
+          </p:cNvPr>
+          <p:cNvSpPr>
+            <a:spLocks xmlns:a="http://schemas.openxmlformats.org/drawingml/2006/main" noGrp="1"/>
+          </p:cNvSpPr>
+          <p:nvPr/>
+        </p:nvSpPr>
+        <p:spPr>
+          <a:xfrm xmlns:a="http://schemas.openxmlformats.org/drawingml/2006/main">
+            <a:off x="1600200" y="14820900"/>
+            <a:ext cx="11087100" cy="1476375"/>
           </a:xfrm>
           <a:prstGeom xmlns:a="http://schemas.openxmlformats.org/drawingml/2006/main" prst="rect">
             <a:avLst/>
@@ -2705,7 +2755,7 @@
                   <a:srgbClr val="102A43"/>
                 </a:solidFill>
               </a:rPr>
-              <a:t>Discovery n=620 · Internal validation n=310</a:t>
+              <a:t>• Discovery n=620 · Internal validation n=310</a:t>
             </a:r>
           </a:p>
           <a:p xmlns:a="http://schemas.openxmlformats.org/drawingml/2006/main">
@@ -2722,7 +2772,7 @@
                   <a:srgbClr val="102A43"/>
                 </a:solidFill>
               </a:rPr>
-              <a:t>External simulation A n=186 · External simulation B n=124</a:t>
+              <a:t>• External A n=186 · External B n=124</a:t>
             </a:r>
           </a:p>
           <a:p xmlns:a="http://schemas.openxmlformats.org/drawingml/2006/main">
@@ -2739,17 +2789,17 @@
                   <a:srgbClr val="102A43"/>
                 </a:solidFill>
               </a:rPr>
-              <a:t>All values are authored fixtures; no participant, specimen, institution, registry or external dataset exists.</a:t>
-            </a:r>
-          </a:p>
-        </p:txBody>
-      </p:sp>
-      <p:sp>
-        <p:nvSpPr>
-          <p:cNvPr id="37" name="dataset-evidence">
-            <a:extLst xmlns:a="http://schemas.openxmlformats.org/drawingml/2006/main">
-              <a:ext uri="{FF2B5EF4-FFF2-40B4-BE49-F238E27FC236}">
-                <a16:creationId xmlns:a16="http://schemas.microsoft.com/office/drawing/2014/main" id="{506B3EA5-8E1C-4A10-BE7E-AE738CB607F7}"/>
+              <a:t>• No participants, specimens or external datasets</a:t>
+            </a:r>
+          </a:p>
+        </p:txBody>
+      </p:sp>
+      <p:sp>
+        <p:nvSpPr>
+          <p:cNvPr id="38" name="dataset-evidence">
+            <a:extLst xmlns:a="http://schemas.openxmlformats.org/drawingml/2006/main">
+              <a:ext uri="{FF2B5EF4-FFF2-40B4-BE49-F238E27FC236}">
+                <a16:creationId xmlns:a16="http://schemas.microsoft.com/office/drawing/2014/main" id="{8CC32DDD-3023-4D0E-8D92-C13D72022433}"/>
               </a:ext>
             </a:extLst>
           </p:cNvPr>
@@ -2777,14 +2827,14 @@
           <a:lstStyle xmlns:a="http://schemas.openxmlformats.org/drawingml/2006/main"/>
           <a:p xmlns:a="http://schemas.openxmlformats.org/drawingml/2006/main">
             <a:pPr>
-              <a:defRPr sz="1875" i="1">
+              <a:defRPr sz="1875">
                 <a:solidFill>
                   <a:srgbClr val="2C8C99"/>
                 </a:solidFill>
               </a:defRPr>
             </a:pPr>
             <a:r>
-              <a:rPr sz="1875" i="1">
+              <a:rPr sz="1875">
                 <a:solidFill>
                   <a:srgbClr val="2C8C99"/>
                 </a:solidFill>
@@ -2796,10 +2846,10 @@
       </p:sp>
       <p:sp>
         <p:nvSpPr>
-          <p:cNvPr id="38" name="figure-one-heading-title">
-            <a:extLst xmlns:a="http://schemas.openxmlformats.org/drawingml/2006/main">
-              <a:ext uri="{FF2B5EF4-FFF2-40B4-BE49-F238E27FC236}">
-                <a16:creationId xmlns:a16="http://schemas.microsoft.com/office/drawing/2014/main" id="{78AD154D-DC55-47E8-A0A2-B77D84F55789}"/>
+          <p:cNvPr id="39" name="figure-one-heading-title">
+            <a:extLst xmlns:a="http://schemas.openxmlformats.org/drawingml/2006/main">
+              <a:ext uri="{FF2B5EF4-FFF2-40B4-BE49-F238E27FC236}">
+                <a16:creationId xmlns:a16="http://schemas.microsoft.com/office/drawing/2014/main" id="{C81E3DC5-E20E-4BD2-AD47-7A8329D1BC1B}"/>
               </a:ext>
             </a:extLst>
           </p:cNvPr>
@@ -2846,10 +2896,10 @@
       </p:sp>
       <p:sp>
         <p:nvSpPr>
-          <p:cNvPr id="39" name="figure-one-heading-rule">
-            <a:extLst xmlns:a="http://schemas.openxmlformats.org/drawingml/2006/main">
-              <a:ext uri="{FF2B5EF4-FFF2-40B4-BE49-F238E27FC236}">
-                <a16:creationId xmlns:a16="http://schemas.microsoft.com/office/drawing/2014/main" id="{D423D96C-1AC5-4B86-A4C0-61CC361B4443}"/>
+          <p:cNvPr id="40" name="figure-one-heading-rule">
+            <a:extLst xmlns:a="http://schemas.openxmlformats.org/drawingml/2006/main">
+              <a:ext uri="{FF2B5EF4-FFF2-40B4-BE49-F238E27FC236}">
+                <a16:creationId xmlns:a16="http://schemas.microsoft.com/office/drawing/2014/main" id="{0AE4E61F-5D80-4E82-BB9C-5F6E3A720D78}"/>
               </a:ext>
             </a:extLst>
           </p:cNvPr>
@@ -2879,10 +2929,10 @@
       </p:sp>
       <p:sp>
         <p:nvSpPr>
-          <p:cNvPr id="40" name="figure-one-frame">
-            <a:extLst xmlns:a="http://schemas.openxmlformats.org/drawingml/2006/main">
-              <a:ext uri="{FF2B5EF4-FFF2-40B4-BE49-F238E27FC236}">
-                <a16:creationId xmlns:a16="http://schemas.microsoft.com/office/drawing/2014/main" id="{77EB65D4-FDD9-409C-AB05-5DA3FE5E878A}"/>
+          <p:cNvPr id="41" name="figure-one-frame">
+            <a:extLst xmlns:a="http://schemas.openxmlformats.org/drawingml/2006/main">
+              <a:ext uri="{FF2B5EF4-FFF2-40B4-BE49-F238E27FC236}">
+                <a16:creationId xmlns:a16="http://schemas.microsoft.com/office/drawing/2014/main" id="{89A32136-1AD8-4768-B6D3-A608D7F96F95}"/>
               </a:ext>
             </a:extLst>
           </p:cNvPr>
@@ -2914,17 +2964,17 @@
       </p:sp>
       <p:pic>
         <p:nvPicPr>
-          <p:cNvPr id="128" name=""/>
+          <p:cNvPr id="131" name=""/>
           <p:cNvPicPr>
             <a:picLocks xmlns:a="http://schemas.openxmlformats.org/drawingml/2006/main" noChangeAspect="1"/>
           </p:cNvPicPr>
           <p:nvPr/>
         </p:nvPicPr>
         <p:blipFill>
-          <a:blip xmlns:r="http://schemas.openxmlformats.org/officeDocument/2006/relationships" xmlns:a="http://schemas.openxmlformats.org/drawingml/2006/main" r:embed="R6b1565952c4f4300">
+          <a:blip xmlns:r="http://schemas.openxmlformats.org/officeDocument/2006/relationships" xmlns:a="http://schemas.openxmlformats.org/drawingml/2006/main" r:embed="R4e19542c18024e67">
             <a:extLst>
               <a:ext uri="{96DAC541-7B7A-43D3-8B79-37D633B846F1}">
-                <asvg:svgBlip xmlns:asvg="http://schemas.microsoft.com/office/drawing/2016/SVG/main" r:embed="R8c9b504dbf554fab"/>
+                <asvg:svgBlip xmlns:asvg="http://schemas.microsoft.com/office/drawing/2016/SVG/main" r:embed="Reb458ce758034afb"/>
               </a:ext>
             </a:extLst>
           </a:blip>
@@ -2942,10 +2992,10 @@
       </p:pic>
       <p:sp>
         <p:nvSpPr>
-          <p:cNvPr id="42" name="figure-one-caption">
-            <a:extLst xmlns:a="http://schemas.openxmlformats.org/drawingml/2006/main">
-              <a:ext uri="{FF2B5EF4-FFF2-40B4-BE49-F238E27FC236}">
-                <a16:creationId xmlns:a16="http://schemas.microsoft.com/office/drawing/2014/main" id="{600F6889-2877-4396-B5A7-A8672CA41B22}"/>
+          <p:cNvPr id="43" name="figure-one-caption">
+            <a:extLst xmlns:a="http://schemas.openxmlformats.org/drawingml/2006/main">
+              <a:ext uri="{FF2B5EF4-FFF2-40B4-BE49-F238E27FC236}">
+                <a16:creationId xmlns:a16="http://schemas.microsoft.com/office/drawing/2014/main" id="{259B04EF-50F9-48BE-BC2A-E24B0C7AFA27}"/>
               </a:ext>
             </a:extLst>
           </p:cNvPr>
@@ -2957,7 +3007,7 @@
         <p:spPr>
           <a:xfrm xmlns:a="http://schemas.openxmlformats.org/drawingml/2006/main">
             <a:off x="1562100" y="27460575"/>
-            <a:ext cx="11163300" cy="400050"/>
+            <a:ext cx="11163300" cy="314325"/>
           </a:xfrm>
           <a:prstGeom xmlns:a="http://schemas.openxmlformats.org/drawingml/2006/main" prst="rect">
             <a:avLst/>
@@ -2992,21 +3042,21 @@
       </p:sp>
       <p:sp>
         <p:nvSpPr>
-          <p:cNvPr id="43" name="figure-one-source">
-            <a:extLst xmlns:a="http://schemas.openxmlformats.org/drawingml/2006/main">
-              <a:ext uri="{FF2B5EF4-FFF2-40B4-BE49-F238E27FC236}">
-                <a16:creationId xmlns:a16="http://schemas.microsoft.com/office/drawing/2014/main" id="{28F157C2-848E-400A-838B-6E0CDEAC1E4D}"/>
-              </a:ext>
-            </a:extLst>
-          </p:cNvPr>
-          <p:cNvSpPr>
-            <a:spLocks xmlns:a="http://schemas.openxmlformats.org/drawingml/2006/main" noGrp="1"/>
-          </p:cNvSpPr>
-          <p:nvPr/>
-        </p:nvSpPr>
-        <p:spPr>
-          <a:xfrm xmlns:a="http://schemas.openxmlformats.org/drawingml/2006/main">
-            <a:off x="1562100" y="27774900"/>
+          <p:cNvPr id="44" name="figure-one-source">
+            <a:extLst xmlns:a="http://schemas.openxmlformats.org/drawingml/2006/main">
+              <a:ext uri="{FF2B5EF4-FFF2-40B4-BE49-F238E27FC236}">
+                <a16:creationId xmlns:a16="http://schemas.microsoft.com/office/drawing/2014/main" id="{554408F4-02C2-4577-A669-E887C36B3C99}"/>
+              </a:ext>
+            </a:extLst>
+          </p:cNvPr>
+          <p:cNvSpPr>
+            <a:spLocks xmlns:a="http://schemas.openxmlformats.org/drawingml/2006/main" noGrp="1"/>
+          </p:cNvSpPr>
+          <p:nvPr/>
+        </p:nvSpPr>
+        <p:spPr>
+          <a:xfrm xmlns:a="http://schemas.openxmlformats.org/drawingml/2006/main">
+            <a:off x="1562100" y="27784425"/>
             <a:ext cx="11163300" cy="361950"/>
           </a:xfrm>
           <a:prstGeom xmlns:a="http://schemas.openxmlformats.org/drawingml/2006/main" prst="rect">
@@ -3023,14 +3073,14 @@
           <a:lstStyle xmlns:a="http://schemas.openxmlformats.org/drawingml/2006/main"/>
           <a:p xmlns:a="http://schemas.openxmlformats.org/drawingml/2006/main">
             <a:pPr>
-              <a:defRPr sz="1875" i="1">
+              <a:defRPr sz="1875">
                 <a:solidFill>
                   <a:srgbClr val="2C8C99"/>
                 </a:solidFill>
               </a:defRPr>
             </a:pPr>
             <a:r>
-              <a:rPr sz="1875" i="1">
+              <a:rPr sz="1875">
                 <a:solidFill>
                   <a:srgbClr val="2C8C99"/>
                 </a:solidFill>
@@ -3042,10 +3092,10 @@
       </p:sp>
       <p:sp>
         <p:nvSpPr>
-          <p:cNvPr id="44" name="central-takeaway">
-            <a:extLst xmlns:a="http://schemas.openxmlformats.org/drawingml/2006/main">
-              <a:ext uri="{FF2B5EF4-FFF2-40B4-BE49-F238E27FC236}">
-                <a16:creationId xmlns:a16="http://schemas.microsoft.com/office/drawing/2014/main" id="{ECA0B784-F8AC-4CEA-919C-FF4572CA85EF}"/>
+          <p:cNvPr id="45" name="central-takeaway">
+            <a:extLst xmlns:a="http://schemas.openxmlformats.org/drawingml/2006/main">
+              <a:ext uri="{FF2B5EF4-FFF2-40B4-BE49-F238E27FC236}">
+                <a16:creationId xmlns:a16="http://schemas.microsoft.com/office/drawing/2014/main" id="{E2C684D2-E8A4-4D1B-A726-7382956AB4A4}"/>
               </a:ext>
             </a:extLst>
           </p:cNvPr>
@@ -3075,10 +3125,10 @@
       </p:sp>
       <p:sp>
         <p:nvSpPr>
-          <p:cNvPr id="45" name="central-takeaway-title">
-            <a:extLst xmlns:a="http://schemas.openxmlformats.org/drawingml/2006/main">
-              <a:ext uri="{FF2B5EF4-FFF2-40B4-BE49-F238E27FC236}">
-                <a16:creationId xmlns:a16="http://schemas.microsoft.com/office/drawing/2014/main" id="{5A883596-F20D-4359-8CBE-39FE4FF86FAC}"/>
+          <p:cNvPr id="46" name="central-takeaway-title">
+            <a:extLst xmlns:a="http://schemas.openxmlformats.org/drawingml/2006/main">
+              <a:ext uri="{FF2B5EF4-FFF2-40B4-BE49-F238E27FC236}">
+                <a16:creationId xmlns:a16="http://schemas.microsoft.com/office/drawing/2014/main" id="{3178D733-C21A-43CD-9743-B3D4F0D3A743}"/>
               </a:ext>
             </a:extLst>
           </p:cNvPr>
@@ -3118,17 +3168,17 @@
                   <a:srgbClr val="102A43"/>
                 </a:solidFill>
               </a:rPr>
-              <a:t>External simulations retained C-indices of 0.75 and 0.74</a:t>
-            </a:r>
-          </a:p>
-        </p:txBody>
-      </p:sp>
-      <p:sp>
-        <p:nvSpPr>
-          <p:cNvPr id="46" name="central-takeaway-subtitle">
-            <a:extLst xmlns:a="http://schemas.openxmlformats.org/drawingml/2006/main">
-              <a:ext uri="{FF2B5EF4-FFF2-40B4-BE49-F238E27FC236}">
-                <a16:creationId xmlns:a16="http://schemas.microsoft.com/office/drawing/2014/main" id="{C70E9D60-D347-460E-80DF-B44F1883B218}"/>
+              <a:t>External C-indices remained 0.75 and 0.74</a:t>
+            </a:r>
+          </a:p>
+        </p:txBody>
+      </p:sp>
+      <p:sp>
+        <p:nvSpPr>
+          <p:cNvPr id="47" name="central-takeaway-subtitle">
+            <a:extLst xmlns:a="http://schemas.openxmlformats.org/drawingml/2006/main">
+              <a:ext uri="{FF2B5EF4-FFF2-40B4-BE49-F238E27FC236}">
+                <a16:creationId xmlns:a16="http://schemas.microsoft.com/office/drawing/2014/main" id="{91CD14D8-A5C4-4C0F-89A1-D9B93FFBF060}"/>
               </a:ext>
             </a:extLst>
           </p:cNvPr>
@@ -3175,10 +3225,10 @@
       </p:sp>
       <p:sp>
         <p:nvSpPr>
-          <p:cNvPr id="47" name="takeaway-evidence">
-            <a:extLst xmlns:a="http://schemas.openxmlformats.org/drawingml/2006/main">
-              <a:ext uri="{FF2B5EF4-FFF2-40B4-BE49-F238E27FC236}">
-                <a16:creationId xmlns:a16="http://schemas.microsoft.com/office/drawing/2014/main" id="{2A0D971A-8CFB-486A-B1CD-3C3F51FB977F}"/>
+          <p:cNvPr id="48" name="takeaway-evidence">
+            <a:extLst xmlns:a="http://schemas.openxmlformats.org/drawingml/2006/main">
+              <a:ext uri="{FF2B5EF4-FFF2-40B4-BE49-F238E27FC236}">
+                <a16:creationId xmlns:a16="http://schemas.microsoft.com/office/drawing/2014/main" id="{AC389CB8-9BA4-46A2-BC85-AC8DEDC46B94}"/>
               </a:ext>
             </a:extLst>
           </p:cNvPr>
@@ -3206,14 +3256,14 @@
           <a:lstStyle xmlns:a="http://schemas.openxmlformats.org/drawingml/2006/main"/>
           <a:p xmlns:a="http://schemas.openxmlformats.org/drawingml/2006/main">
             <a:pPr>
-              <a:defRPr sz="1875" i="1">
+              <a:defRPr sz="1875">
                 <a:solidFill>
                   <a:srgbClr val="2C8C99"/>
                 </a:solidFill>
               </a:defRPr>
             </a:pPr>
             <a:r>
-              <a:rPr sz="1875" i="1">
+              <a:rPr sz="1875">
                 <a:solidFill>
                   <a:srgbClr val="2C8C99"/>
                 </a:solidFill>
@@ -3225,10 +3275,10 @@
       </p:sp>
       <p:sp>
         <p:nvSpPr>
-          <p:cNvPr id="48" name="figure-two-heading-title">
-            <a:extLst xmlns:a="http://schemas.openxmlformats.org/drawingml/2006/main">
-              <a:ext uri="{FF2B5EF4-FFF2-40B4-BE49-F238E27FC236}">
-                <a16:creationId xmlns:a16="http://schemas.microsoft.com/office/drawing/2014/main" id="{93F75617-1520-4809-8AD2-D9E71643C21A}"/>
+          <p:cNvPr id="49" name="figure-two-heading-title">
+            <a:extLst xmlns:a="http://schemas.openxmlformats.org/drawingml/2006/main">
+              <a:ext uri="{FF2B5EF4-FFF2-40B4-BE49-F238E27FC236}">
+                <a16:creationId xmlns:a16="http://schemas.microsoft.com/office/drawing/2014/main" id="{1A17EFBD-D676-4DD7-9D3A-FF939D32ADEA}"/>
               </a:ext>
             </a:extLst>
           </p:cNvPr>
@@ -3275,10 +3325,10 @@
       </p:sp>
       <p:sp>
         <p:nvSpPr>
-          <p:cNvPr id="49" name="figure-two-heading-rule">
-            <a:extLst xmlns:a="http://schemas.openxmlformats.org/drawingml/2006/main">
-              <a:ext uri="{FF2B5EF4-FFF2-40B4-BE49-F238E27FC236}">
-                <a16:creationId xmlns:a16="http://schemas.microsoft.com/office/drawing/2014/main" id="{93D1EF55-9AE8-41AA-8B02-9A56C0AC5B0F}"/>
+          <p:cNvPr id="50" name="figure-two-heading-rule">
+            <a:extLst xmlns:a="http://schemas.openxmlformats.org/drawingml/2006/main">
+              <a:ext uri="{FF2B5EF4-FFF2-40B4-BE49-F238E27FC236}">
+                <a16:creationId xmlns:a16="http://schemas.microsoft.com/office/drawing/2014/main" id="{7A596253-28EE-4C28-8A70-59259C90B6AB}"/>
               </a:ext>
             </a:extLst>
           </p:cNvPr>
@@ -3308,10 +3358,10 @@
       </p:sp>
       <p:sp>
         <p:nvSpPr>
-          <p:cNvPr id="50" name="figure-two-frame">
-            <a:extLst xmlns:a="http://schemas.openxmlformats.org/drawingml/2006/main">
-              <a:ext uri="{FF2B5EF4-FFF2-40B4-BE49-F238E27FC236}">
-                <a16:creationId xmlns:a16="http://schemas.microsoft.com/office/drawing/2014/main" id="{0FCB1741-6384-4527-AA01-DC5B4B77A5A0}"/>
+          <p:cNvPr id="51" name="figure-two-frame">
+            <a:extLst xmlns:a="http://schemas.openxmlformats.org/drawingml/2006/main">
+              <a:ext uri="{FF2B5EF4-FFF2-40B4-BE49-F238E27FC236}">
+                <a16:creationId xmlns:a16="http://schemas.microsoft.com/office/drawing/2014/main" id="{C1B04EBE-9DAA-4C06-86E7-34F3207EFF09}"/>
               </a:ext>
             </a:extLst>
           </p:cNvPr>
@@ -3343,17 +3393,17 @@
       </p:sp>
       <p:pic>
         <p:nvPicPr>
-          <p:cNvPr id="138" name=""/>
+          <p:cNvPr id="141" name=""/>
           <p:cNvPicPr>
             <a:picLocks xmlns:a="http://schemas.openxmlformats.org/drawingml/2006/main" noChangeAspect="1"/>
           </p:cNvPicPr>
           <p:nvPr/>
         </p:nvPicPr>
         <p:blipFill>
-          <a:blip xmlns:r="http://schemas.openxmlformats.org/officeDocument/2006/relationships" xmlns:a="http://schemas.openxmlformats.org/drawingml/2006/main" r:embed="R8c9d1c8915174c64">
+          <a:blip xmlns:r="http://schemas.openxmlformats.org/officeDocument/2006/relationships" xmlns:a="http://schemas.openxmlformats.org/drawingml/2006/main" r:embed="R18ca1ec79fec4c30">
             <a:extLst>
               <a:ext uri="{96DAC541-7B7A-43D3-8B79-37D633B846F1}">
-                <asvg:svgBlip xmlns:asvg="http://schemas.microsoft.com/office/drawing/2016/SVG/main" r:embed="Rb7d006c649424665"/>
+                <asvg:svgBlip xmlns:asvg="http://schemas.microsoft.com/office/drawing/2016/SVG/main" r:embed="Re5a5c17e69524412"/>
               </a:ext>
             </a:extLst>
           </a:blip>
@@ -3371,10 +3421,10 @@
       </p:pic>
       <p:sp>
         <p:nvSpPr>
-          <p:cNvPr id="52" name="figure-two-caption">
-            <a:extLst xmlns:a="http://schemas.openxmlformats.org/drawingml/2006/main">
-              <a:ext uri="{FF2B5EF4-FFF2-40B4-BE49-F238E27FC236}">
-                <a16:creationId xmlns:a16="http://schemas.microsoft.com/office/drawing/2014/main" id="{C91EE88A-A256-41E3-AB5E-24C2C43565CC}"/>
+          <p:cNvPr id="53" name="figure-two-caption">
+            <a:extLst xmlns:a="http://schemas.openxmlformats.org/drawingml/2006/main">
+              <a:ext uri="{FF2B5EF4-FFF2-40B4-BE49-F238E27FC236}">
+                <a16:creationId xmlns:a16="http://schemas.microsoft.com/office/drawing/2014/main" id="{7AF2DC73-3A3E-4363-AF48-DE17B0E6EF62}"/>
               </a:ext>
             </a:extLst>
           </p:cNvPr>
@@ -3386,7 +3436,7 @@
         <p:spPr>
           <a:xfrm xmlns:a="http://schemas.openxmlformats.org/drawingml/2006/main">
             <a:off x="13754100" y="21507450"/>
-            <a:ext cx="13211175" cy="400050"/>
+            <a:ext cx="13211175" cy="314325"/>
           </a:xfrm>
           <a:prstGeom xmlns:a="http://schemas.openxmlformats.org/drawingml/2006/main" prst="rect">
             <a:avLst/>
@@ -3421,21 +3471,21 @@
       </p:sp>
       <p:sp>
         <p:nvSpPr>
-          <p:cNvPr id="53" name="figure-two-source">
-            <a:extLst xmlns:a="http://schemas.openxmlformats.org/drawingml/2006/main">
-              <a:ext uri="{FF2B5EF4-FFF2-40B4-BE49-F238E27FC236}">
-                <a16:creationId xmlns:a16="http://schemas.microsoft.com/office/drawing/2014/main" id="{A74D7F43-89B4-4743-938A-A1D56699EDFF}"/>
-              </a:ext>
-            </a:extLst>
-          </p:cNvPr>
-          <p:cNvSpPr>
-            <a:spLocks xmlns:a="http://schemas.openxmlformats.org/drawingml/2006/main" noGrp="1"/>
-          </p:cNvSpPr>
-          <p:nvPr/>
-        </p:nvSpPr>
-        <p:spPr>
-          <a:xfrm xmlns:a="http://schemas.openxmlformats.org/drawingml/2006/main">
-            <a:off x="13754100" y="21821775"/>
+          <p:cNvPr id="54" name="figure-two-source">
+            <a:extLst xmlns:a="http://schemas.openxmlformats.org/drawingml/2006/main">
+              <a:ext uri="{FF2B5EF4-FFF2-40B4-BE49-F238E27FC236}">
+                <a16:creationId xmlns:a16="http://schemas.microsoft.com/office/drawing/2014/main" id="{D8A94476-9337-46B1-BCF8-DC44D9ED5E49}"/>
+              </a:ext>
+            </a:extLst>
+          </p:cNvPr>
+          <p:cNvSpPr>
+            <a:spLocks xmlns:a="http://schemas.openxmlformats.org/drawingml/2006/main" noGrp="1"/>
+          </p:cNvSpPr>
+          <p:nvPr/>
+        </p:nvSpPr>
+        <p:spPr>
+          <a:xfrm xmlns:a="http://schemas.openxmlformats.org/drawingml/2006/main">
+            <a:off x="13754100" y="21831300"/>
             <a:ext cx="13211175" cy="361950"/>
           </a:xfrm>
           <a:prstGeom xmlns:a="http://schemas.openxmlformats.org/drawingml/2006/main" prst="rect">
@@ -3452,14 +3502,14 @@
           <a:lstStyle xmlns:a="http://schemas.openxmlformats.org/drawingml/2006/main"/>
           <a:p xmlns:a="http://schemas.openxmlformats.org/drawingml/2006/main">
             <a:pPr>
-              <a:defRPr sz="1875" i="1">
+              <a:defRPr sz="1875">
                 <a:solidFill>
                   <a:srgbClr val="2C8C99"/>
                 </a:solidFill>
               </a:defRPr>
             </a:pPr>
             <a:r>
-              <a:rPr sz="1875" i="1">
+              <a:rPr sz="1875">
                 <a:solidFill>
                   <a:srgbClr val="2C8C99"/>
                 </a:solidFill>
@@ -3471,10 +3521,10 @@
       </p:sp>
       <p:sp>
         <p:nvSpPr>
-          <p:cNvPr id="54" name="validation-heading-title">
-            <a:extLst xmlns:a="http://schemas.openxmlformats.org/drawingml/2006/main">
-              <a:ext uri="{FF2B5EF4-FFF2-40B4-BE49-F238E27FC236}">
-                <a16:creationId xmlns:a16="http://schemas.microsoft.com/office/drawing/2014/main" id="{FC6EBB6D-E562-4B0B-93AB-229169524203}"/>
+          <p:cNvPr id="55" name="validation-heading-title">
+            <a:extLst xmlns:a="http://schemas.openxmlformats.org/drawingml/2006/main">
+              <a:ext uri="{FF2B5EF4-FFF2-40B4-BE49-F238E27FC236}">
+                <a16:creationId xmlns:a16="http://schemas.microsoft.com/office/drawing/2014/main" id="{4CCF7FE3-A2A2-46EF-956C-E226A94FB407}"/>
               </a:ext>
             </a:extLst>
           </p:cNvPr>
@@ -3521,10 +3571,10 @@
       </p:sp>
       <p:sp>
         <p:nvSpPr>
-          <p:cNvPr id="55" name="validation-heading-rule">
-            <a:extLst xmlns:a="http://schemas.openxmlformats.org/drawingml/2006/main">
-              <a:ext uri="{FF2B5EF4-FFF2-40B4-BE49-F238E27FC236}">
-                <a16:creationId xmlns:a16="http://schemas.microsoft.com/office/drawing/2014/main" id="{ADF86218-4202-4DFF-9AED-B06561DF8858}"/>
+          <p:cNvPr id="56" name="validation-heading-rule">
+            <a:extLst xmlns:a="http://schemas.openxmlformats.org/drawingml/2006/main">
+              <a:ext uri="{FF2B5EF4-FFF2-40B4-BE49-F238E27FC236}">
+                <a16:creationId xmlns:a16="http://schemas.microsoft.com/office/drawing/2014/main" id="{235FCA53-7673-4D61-99BE-3050D2001831}"/>
               </a:ext>
             </a:extLst>
           </p:cNvPr>
@@ -3554,10 +3604,10 @@
       </p:sp>
       <p:sp>
         <p:nvSpPr>
-          <p:cNvPr id="56" name="validation-panel">
-            <a:extLst xmlns:a="http://schemas.openxmlformats.org/drawingml/2006/main">
-              <a:ext uri="{FF2B5EF4-FFF2-40B4-BE49-F238E27FC236}">
-                <a16:creationId xmlns:a16="http://schemas.microsoft.com/office/drawing/2014/main" id="{887CA80D-CBFD-4A1A-A7FE-DBD1B8DFE736}"/>
+          <p:cNvPr id="57" name="validation-panel">
+            <a:extLst xmlns:a="http://schemas.openxmlformats.org/drawingml/2006/main">
+              <a:ext uri="{FF2B5EF4-FFF2-40B4-BE49-F238E27FC236}">
+                <a16:creationId xmlns:a16="http://schemas.microsoft.com/office/drawing/2014/main" id="{2867C99F-A8E0-4E59-8E78-1E9163572AFF}"/>
               </a:ext>
             </a:extLst>
           </p:cNvPr>
@@ -3589,10 +3639,10 @@
       </p:sp>
       <p:sp>
         <p:nvSpPr>
-          <p:cNvPr id="57" name="validation">
-            <a:extLst xmlns:a="http://schemas.openxmlformats.org/drawingml/2006/main">
-              <a:ext uri="{FF2B5EF4-FFF2-40B4-BE49-F238E27FC236}">
-                <a16:creationId xmlns:a16="http://schemas.microsoft.com/office/drawing/2014/main" id="{62A2A3D5-63C3-4A9F-BB26-297960E50F9F}"/>
+          <p:cNvPr id="58" name="validation">
+            <a:extLst xmlns:a="http://schemas.openxmlformats.org/drawingml/2006/main">
+              <a:ext uri="{FF2B5EF4-FFF2-40B4-BE49-F238E27FC236}">
+                <a16:creationId xmlns:a16="http://schemas.microsoft.com/office/drawing/2014/main" id="{6B543882-055A-4356-A4C2-F75AB3ECC713}"/>
               </a:ext>
             </a:extLst>
           </p:cNvPr>
@@ -3690,10 +3740,10 @@
       </p:sp>
       <p:sp>
         <p:nvSpPr>
-          <p:cNvPr id="58" name="validation-evidence">
-            <a:extLst xmlns:a="http://schemas.openxmlformats.org/drawingml/2006/main">
-              <a:ext uri="{FF2B5EF4-FFF2-40B4-BE49-F238E27FC236}">
-                <a16:creationId xmlns:a16="http://schemas.microsoft.com/office/drawing/2014/main" id="{5DEA038C-0655-45A2-A050-D7007C828FD5}"/>
+          <p:cNvPr id="59" name="validation-evidence">
+            <a:extLst xmlns:a="http://schemas.openxmlformats.org/drawingml/2006/main">
+              <a:ext uri="{FF2B5EF4-FFF2-40B4-BE49-F238E27FC236}">
+                <a16:creationId xmlns:a16="http://schemas.microsoft.com/office/drawing/2014/main" id="{318B82CA-AE77-4A0F-ADAB-C42F8830F91D}"/>
               </a:ext>
             </a:extLst>
           </p:cNvPr>
@@ -3721,14 +3771,14 @@
           <a:lstStyle xmlns:a="http://schemas.openxmlformats.org/drawingml/2006/main"/>
           <a:p xmlns:a="http://schemas.openxmlformats.org/drawingml/2006/main">
             <a:pPr>
-              <a:defRPr sz="1875" i="1">
+              <a:defRPr sz="1875">
                 <a:solidFill>
                   <a:srgbClr val="2C8C99"/>
                 </a:solidFill>
               </a:defRPr>
             </a:pPr>
             <a:r>
-              <a:rPr sz="1875" i="1">
+              <a:rPr sz="1875">
                 <a:solidFill>
                   <a:srgbClr val="2C8C99"/>
                 </a:solidFill>
@@ -3740,10 +3790,10 @@
       </p:sp>
       <p:sp>
         <p:nvSpPr>
-          <p:cNvPr id="59" name="performance-strip">
-            <a:extLst xmlns:a="http://schemas.openxmlformats.org/drawingml/2006/main">
-              <a:ext uri="{FF2B5EF4-FFF2-40B4-BE49-F238E27FC236}">
-                <a16:creationId xmlns:a16="http://schemas.microsoft.com/office/drawing/2014/main" id="{739FFA4B-FEBD-4373-9E11-81F222D130E3}"/>
+          <p:cNvPr id="60" name="performance-strip">
+            <a:extLst xmlns:a="http://schemas.openxmlformats.org/drawingml/2006/main">
+              <a:ext uri="{FF2B5EF4-FFF2-40B4-BE49-F238E27FC236}">
+                <a16:creationId xmlns:a16="http://schemas.microsoft.com/office/drawing/2014/main" id="{5169990B-317F-4D7D-9761-0448DD76DE51}"/>
               </a:ext>
             </a:extLst>
           </p:cNvPr>
@@ -3773,10 +3823,10 @@
       </p:sp>
       <p:sp>
         <p:nvSpPr>
-          <p:cNvPr id="60" name="performance-strip-text">
-            <a:extLst xmlns:a="http://schemas.openxmlformats.org/drawingml/2006/main">
-              <a:ext uri="{FF2B5EF4-FFF2-40B4-BE49-F238E27FC236}">
-                <a16:creationId xmlns:a16="http://schemas.microsoft.com/office/drawing/2014/main" id="{766473C8-8C40-42C7-A2C1-64F2E45ECD8E}"/>
+          <p:cNvPr id="61" name="performance-strip-text">
+            <a:extLst xmlns:a="http://schemas.openxmlformats.org/drawingml/2006/main">
+              <a:ext uri="{FF2B5EF4-FFF2-40B4-BE49-F238E27FC236}">
+                <a16:creationId xmlns:a16="http://schemas.microsoft.com/office/drawing/2014/main" id="{F9405E43-CF8F-473E-8F7D-0D0BB78956B8}"/>
               </a:ext>
             </a:extLst>
           </p:cNvPr>
@@ -3816,17 +3866,17 @@
                   <a:srgbClr val="FFFFFF"/>
                 </a:solidFill>
               </a:rPr>
-              <a:t>AURORA-12 vs baseline C-index · Discovery 0.78 vs 0.68 · Internal 0.76 vs 0.67 · External A 0.75 vs 0.66 · External B 0.74 vs 0.65</a:t>
-            </a:r>
-          </a:p>
-        </p:txBody>
-      </p:sp>
-      <p:sp>
-        <p:nvSpPr>
-          <p:cNvPr id="61" name="biology-heading-title">
-            <a:extLst xmlns:a="http://schemas.openxmlformats.org/drawingml/2006/main">
-              <a:ext uri="{FF2B5EF4-FFF2-40B4-BE49-F238E27FC236}">
-                <a16:creationId xmlns:a16="http://schemas.microsoft.com/office/drawing/2014/main" id="{78263B02-DD54-41A5-8261-81640207A485}"/>
+              <a:t>External validation retained discrimination: C-index 0.75 / 0.74</a:t>
+            </a:r>
+          </a:p>
+        </p:txBody>
+      </p:sp>
+      <p:sp>
+        <p:nvSpPr>
+          <p:cNvPr id="62" name="biology-heading-title">
+            <a:extLst xmlns:a="http://schemas.openxmlformats.org/drawingml/2006/main">
+              <a:ext uri="{FF2B5EF4-FFF2-40B4-BE49-F238E27FC236}">
+                <a16:creationId xmlns:a16="http://schemas.microsoft.com/office/drawing/2014/main" id="{6BC50FE4-8AA7-4B4A-8A5D-768418B83BC7}"/>
               </a:ext>
             </a:extLst>
           </p:cNvPr>
@@ -3873,10 +3923,10 @@
       </p:sp>
       <p:sp>
         <p:nvSpPr>
-          <p:cNvPr id="62" name="biology-heading-rule">
-            <a:extLst xmlns:a="http://schemas.openxmlformats.org/drawingml/2006/main">
-              <a:ext uri="{FF2B5EF4-FFF2-40B4-BE49-F238E27FC236}">
-                <a16:creationId xmlns:a16="http://schemas.microsoft.com/office/drawing/2014/main" id="{7DE865FF-BE22-41C5-AD45-6BC1E38F6B39}"/>
+          <p:cNvPr id="63" name="biology-heading-rule">
+            <a:extLst xmlns:a="http://schemas.openxmlformats.org/drawingml/2006/main">
+              <a:ext uri="{FF2B5EF4-FFF2-40B4-BE49-F238E27FC236}">
+                <a16:creationId xmlns:a16="http://schemas.microsoft.com/office/drawing/2014/main" id="{1C0341B5-9404-4B52-9EF2-383CC49764EC}"/>
               </a:ext>
             </a:extLst>
           </p:cNvPr>
@@ -3906,10 +3956,10 @@
       </p:sp>
       <p:sp>
         <p:nvSpPr>
-          <p:cNvPr id="63" name="biology-1-value">
-            <a:extLst xmlns:a="http://schemas.openxmlformats.org/drawingml/2006/main">
-              <a:ext uri="{FF2B5EF4-FFF2-40B4-BE49-F238E27FC236}">
-                <a16:creationId xmlns:a16="http://schemas.microsoft.com/office/drawing/2014/main" id="{3F7BEA19-5D31-4B69-8E28-987F07551366}"/>
+          <p:cNvPr id="64" name="biology-1-value">
+            <a:extLst xmlns:a="http://schemas.openxmlformats.org/drawingml/2006/main">
+              <a:ext uri="{FF2B5EF4-FFF2-40B4-BE49-F238E27FC236}">
+                <a16:creationId xmlns:a16="http://schemas.microsoft.com/office/drawing/2014/main" id="{7DF14F3F-52DE-4BD1-B4B9-27A3007A5FBB}"/>
               </a:ext>
             </a:extLst>
           </p:cNvPr>
@@ -3956,21 +4006,21 @@
       </p:sp>
       <p:sp>
         <p:nvSpPr>
-          <p:cNvPr id="64" name="biology-1-label">
-            <a:extLst xmlns:a="http://schemas.openxmlformats.org/drawingml/2006/main">
-              <a:ext uri="{FF2B5EF4-FFF2-40B4-BE49-F238E27FC236}">
-                <a16:creationId xmlns:a16="http://schemas.microsoft.com/office/drawing/2014/main" id="{B77C36C3-AFDB-43B2-BFA6-805E1D83D9D3}"/>
-              </a:ext>
-            </a:extLst>
-          </p:cNvPr>
-          <p:cNvSpPr>
-            <a:spLocks xmlns:a="http://schemas.openxmlformats.org/drawingml/2006/main" noGrp="1"/>
-          </p:cNvSpPr>
-          <p:nvPr/>
-        </p:nvSpPr>
-        <p:spPr>
-          <a:xfrm xmlns:a="http://schemas.openxmlformats.org/drawingml/2006/main">
-            <a:off x="27765375" y="7353300"/>
+          <p:cNvPr id="65" name="biology-1-label">
+            <a:extLst xmlns:a="http://schemas.openxmlformats.org/drawingml/2006/main">
+              <a:ext uri="{FF2B5EF4-FFF2-40B4-BE49-F238E27FC236}">
+                <a16:creationId xmlns:a16="http://schemas.microsoft.com/office/drawing/2014/main" id="{03D1B7E4-0CE7-40D2-BA8B-0C1EBFEA36A6}"/>
+              </a:ext>
+            </a:extLst>
+          </p:cNvPr>
+          <p:cNvSpPr>
+            <a:spLocks xmlns:a="http://schemas.openxmlformats.org/drawingml/2006/main" noGrp="1"/>
+          </p:cNvSpPr>
+          <p:nvPr/>
+        </p:nvSpPr>
+        <p:spPr>
+          <a:xfrm xmlns:a="http://schemas.openxmlformats.org/drawingml/2006/main">
+            <a:off x="27765375" y="7315200"/>
             <a:ext cx="4000500" cy="838200"/>
           </a:xfrm>
           <a:prstGeom xmlns:a="http://schemas.openxmlformats.org/drawingml/2006/main" prst="rect">
@@ -4006,10 +4056,10 @@
       </p:sp>
       <p:sp>
         <p:nvSpPr>
-          <p:cNvPr id="65" name="biology-2-value">
-            <a:extLst xmlns:a="http://schemas.openxmlformats.org/drawingml/2006/main">
-              <a:ext uri="{FF2B5EF4-FFF2-40B4-BE49-F238E27FC236}">
-                <a16:creationId xmlns:a16="http://schemas.microsoft.com/office/drawing/2014/main" id="{681C92D0-236D-4563-86E5-76461D66CA21}"/>
+          <p:cNvPr id="66" name="biology-2-value">
+            <a:extLst xmlns:a="http://schemas.openxmlformats.org/drawingml/2006/main">
+              <a:ext uri="{FF2B5EF4-FFF2-40B4-BE49-F238E27FC236}">
+                <a16:creationId xmlns:a16="http://schemas.microsoft.com/office/drawing/2014/main" id="{7DEF9E9F-4266-4AEB-A964-3AC94FC4DC2B}"/>
               </a:ext>
             </a:extLst>
           </p:cNvPr>
@@ -4056,21 +4106,21 @@
       </p:sp>
       <p:sp>
         <p:nvSpPr>
-          <p:cNvPr id="66" name="biology-2-label">
-            <a:extLst xmlns:a="http://schemas.openxmlformats.org/drawingml/2006/main">
-              <a:ext uri="{FF2B5EF4-FFF2-40B4-BE49-F238E27FC236}">
-                <a16:creationId xmlns:a16="http://schemas.microsoft.com/office/drawing/2014/main" id="{6DEB8577-6A4B-41F6-8D31-7A7CE2E2E442}"/>
-              </a:ext>
-            </a:extLst>
-          </p:cNvPr>
-          <p:cNvSpPr>
-            <a:spLocks xmlns:a="http://schemas.openxmlformats.org/drawingml/2006/main" noGrp="1"/>
-          </p:cNvSpPr>
-          <p:nvPr/>
-        </p:nvSpPr>
-        <p:spPr>
-          <a:xfrm xmlns:a="http://schemas.openxmlformats.org/drawingml/2006/main">
-            <a:off x="32289750" y="7353300"/>
+          <p:cNvPr id="67" name="biology-2-label">
+            <a:extLst xmlns:a="http://schemas.openxmlformats.org/drawingml/2006/main">
+              <a:ext uri="{FF2B5EF4-FFF2-40B4-BE49-F238E27FC236}">
+                <a16:creationId xmlns:a16="http://schemas.microsoft.com/office/drawing/2014/main" id="{955A7862-C8C2-488E-A11E-85984FAFA944}"/>
+              </a:ext>
+            </a:extLst>
+          </p:cNvPr>
+          <p:cNvSpPr>
+            <a:spLocks xmlns:a="http://schemas.openxmlformats.org/drawingml/2006/main" noGrp="1"/>
+          </p:cNvSpPr>
+          <p:nvPr/>
+        </p:nvSpPr>
+        <p:spPr>
+          <a:xfrm xmlns:a="http://schemas.openxmlformats.org/drawingml/2006/main">
+            <a:off x="32289750" y="7315200"/>
             <a:ext cx="4000500" cy="838200"/>
           </a:xfrm>
           <a:prstGeom xmlns:a="http://schemas.openxmlformats.org/drawingml/2006/main" prst="rect">
@@ -4106,10 +4156,10 @@
       </p:sp>
       <p:sp>
         <p:nvSpPr>
-          <p:cNvPr id="67" name="biology-3-value">
-            <a:extLst xmlns:a="http://schemas.openxmlformats.org/drawingml/2006/main">
-              <a:ext uri="{FF2B5EF4-FFF2-40B4-BE49-F238E27FC236}">
-                <a16:creationId xmlns:a16="http://schemas.microsoft.com/office/drawing/2014/main" id="{B25252C5-EC3D-45E6-8A5C-B2850666B481}"/>
+          <p:cNvPr id="68" name="biology-3-value">
+            <a:extLst xmlns:a="http://schemas.openxmlformats.org/drawingml/2006/main">
+              <a:ext uri="{FF2B5EF4-FFF2-40B4-BE49-F238E27FC236}">
+                <a16:creationId xmlns:a16="http://schemas.microsoft.com/office/drawing/2014/main" id="{D40D03C9-1CC8-475D-88BA-2E6BE4521F0B}"/>
               </a:ext>
             </a:extLst>
           </p:cNvPr>
@@ -4137,14 +4187,14 @@
           <a:lstStyle xmlns:a="http://schemas.openxmlformats.org/drawingml/2006/main"/>
           <a:p xmlns:a="http://schemas.openxmlformats.org/drawingml/2006/main">
             <a:pPr>
-              <a:defRPr sz="5100" b="1">
+              <a:defRPr sz="4125" b="1">
                 <a:solidFill>
                   <a:srgbClr val="E8B44C"/>
                 </a:solidFill>
               </a:defRPr>
             </a:pPr>
             <a:r>
-              <a:rPr sz="5100" b="1">
+              <a:rPr sz="4125" b="1">
                 <a:solidFill>
                   <a:srgbClr val="E8B44C"/>
                 </a:solidFill>
@@ -4156,21 +4206,21 @@
       </p:sp>
       <p:sp>
         <p:nvSpPr>
-          <p:cNvPr id="68" name="biology-3-label">
-            <a:extLst xmlns:a="http://schemas.openxmlformats.org/drawingml/2006/main">
-              <a:ext uri="{FF2B5EF4-FFF2-40B4-BE49-F238E27FC236}">
-                <a16:creationId xmlns:a16="http://schemas.microsoft.com/office/drawing/2014/main" id="{21DE78D6-0E03-41E0-9AA8-97AE7074E253}"/>
-              </a:ext>
-            </a:extLst>
-          </p:cNvPr>
-          <p:cNvSpPr>
-            <a:spLocks xmlns:a="http://schemas.openxmlformats.org/drawingml/2006/main" noGrp="1"/>
-          </p:cNvSpPr>
-          <p:nvPr/>
-        </p:nvSpPr>
-        <p:spPr>
-          <a:xfrm xmlns:a="http://schemas.openxmlformats.org/drawingml/2006/main">
-            <a:off x="36814125" y="7353300"/>
+          <p:cNvPr id="69" name="biology-3-label">
+            <a:extLst xmlns:a="http://schemas.openxmlformats.org/drawingml/2006/main">
+              <a:ext uri="{FF2B5EF4-FFF2-40B4-BE49-F238E27FC236}">
+                <a16:creationId xmlns:a16="http://schemas.microsoft.com/office/drawing/2014/main" id="{474BD127-C0A0-4A44-9A7F-30D2AF83C7DC}"/>
+              </a:ext>
+            </a:extLst>
+          </p:cNvPr>
+          <p:cNvSpPr>
+            <a:spLocks xmlns:a="http://schemas.openxmlformats.org/drawingml/2006/main" noGrp="1"/>
+          </p:cNvSpPr>
+          <p:nvPr/>
+        </p:nvSpPr>
+        <p:spPr>
+          <a:xfrm xmlns:a="http://schemas.openxmlformats.org/drawingml/2006/main">
+            <a:off x="36814125" y="7315200"/>
             <a:ext cx="4000500" cy="838200"/>
           </a:xfrm>
           <a:prstGeom xmlns:a="http://schemas.openxmlformats.org/drawingml/2006/main" prst="rect">
@@ -4206,10 +4256,10 @@
       </p:sp>
       <p:sp>
         <p:nvSpPr>
-          <p:cNvPr id="69" name="biology-evidence">
-            <a:extLst xmlns:a="http://schemas.openxmlformats.org/drawingml/2006/main">
-              <a:ext uri="{FF2B5EF4-FFF2-40B4-BE49-F238E27FC236}">
-                <a16:creationId xmlns:a16="http://schemas.microsoft.com/office/drawing/2014/main" id="{C725240F-C5CC-4BC8-9903-34C4E655D087}"/>
+          <p:cNvPr id="70" name="biology-evidence">
+            <a:extLst xmlns:a="http://schemas.openxmlformats.org/drawingml/2006/main">
+              <a:ext uri="{FF2B5EF4-FFF2-40B4-BE49-F238E27FC236}">
+                <a16:creationId xmlns:a16="http://schemas.microsoft.com/office/drawing/2014/main" id="{F7664907-6081-4338-BC2D-09F2444B70BE}"/>
               </a:ext>
             </a:extLst>
           </p:cNvPr>
@@ -4237,14 +4287,14 @@
           <a:lstStyle xmlns:a="http://schemas.openxmlformats.org/drawingml/2006/main"/>
           <a:p xmlns:a="http://schemas.openxmlformats.org/drawingml/2006/main">
             <a:pPr>
-              <a:defRPr sz="1875" i="1">
+              <a:defRPr sz="1875">
                 <a:solidFill>
                   <a:srgbClr val="2C8C99"/>
                 </a:solidFill>
               </a:defRPr>
             </a:pPr>
             <a:r>
-              <a:rPr sz="1875" i="1">
+              <a:rPr sz="1875">
                 <a:solidFill>
                   <a:srgbClr val="2C8C99"/>
                 </a:solidFill>
@@ -4256,10 +4306,10 @@
       </p:sp>
       <p:sp>
         <p:nvSpPr>
-          <p:cNvPr id="70" name="figure-three-frame">
-            <a:extLst xmlns:a="http://schemas.openxmlformats.org/drawingml/2006/main">
-              <a:ext uri="{FF2B5EF4-FFF2-40B4-BE49-F238E27FC236}">
-                <a16:creationId xmlns:a16="http://schemas.microsoft.com/office/drawing/2014/main" id="{D148CA4E-CCAB-4831-A0A8-AA14962E914C}"/>
+          <p:cNvPr id="71" name="figure-three-frame">
+            <a:extLst xmlns:a="http://schemas.openxmlformats.org/drawingml/2006/main">
+              <a:ext uri="{FF2B5EF4-FFF2-40B4-BE49-F238E27FC236}">
+                <a16:creationId xmlns:a16="http://schemas.microsoft.com/office/drawing/2014/main" id="{451A16EE-7D45-4A5B-87ED-68CF5C5F5806}"/>
               </a:ext>
             </a:extLst>
           </p:cNvPr>
@@ -4291,17 +4341,17 @@
       </p:sp>
       <p:pic>
         <p:nvPicPr>
-          <p:cNvPr id="158" name=""/>
+          <p:cNvPr id="161" name=""/>
           <p:cNvPicPr>
             <a:picLocks xmlns:a="http://schemas.openxmlformats.org/drawingml/2006/main" noChangeAspect="1"/>
           </p:cNvPicPr>
           <p:nvPr/>
         </p:nvPicPr>
         <p:blipFill>
-          <a:blip xmlns:r="http://schemas.openxmlformats.org/officeDocument/2006/relationships" xmlns:a="http://schemas.openxmlformats.org/drawingml/2006/main" r:embed="Rbdcbb2b7fe53480e">
+          <a:blip xmlns:r="http://schemas.openxmlformats.org/officeDocument/2006/relationships" xmlns:a="http://schemas.openxmlformats.org/drawingml/2006/main" r:embed="Rf0e73b21c8f94f46">
             <a:extLst>
               <a:ext uri="{96DAC541-7B7A-43D3-8B79-37D633B846F1}">
-                <asvg:svgBlip xmlns:asvg="http://schemas.microsoft.com/office/drawing/2016/SVG/main" r:embed="Rc95c101a1bf44ae4"/>
+                <asvg:svgBlip xmlns:asvg="http://schemas.microsoft.com/office/drawing/2016/SVG/main" r:embed="R5a2ce9703184438f"/>
               </a:ext>
             </a:extLst>
           </a:blip>
@@ -4319,10 +4369,10 @@
       </p:pic>
       <p:sp>
         <p:nvSpPr>
-          <p:cNvPr id="72" name="figure-three-caption">
-            <a:extLst xmlns:a="http://schemas.openxmlformats.org/drawingml/2006/main">
-              <a:ext uri="{FF2B5EF4-FFF2-40B4-BE49-F238E27FC236}">
-                <a16:creationId xmlns:a16="http://schemas.microsoft.com/office/drawing/2014/main" id="{F3ECA723-DAD3-462D-B2C0-E4B301B91C6A}"/>
+          <p:cNvPr id="73" name="figure-three-caption">
+            <a:extLst xmlns:a="http://schemas.openxmlformats.org/drawingml/2006/main">
+              <a:ext uri="{FF2B5EF4-FFF2-40B4-BE49-F238E27FC236}">
+                <a16:creationId xmlns:a16="http://schemas.microsoft.com/office/drawing/2014/main" id="{487B7FBC-5A5C-43FF-B7CE-62E8E5B25B70}"/>
               </a:ext>
             </a:extLst>
           </p:cNvPr>
@@ -4334,7 +4384,7 @@
         <p:spPr>
           <a:xfrm xmlns:a="http://schemas.openxmlformats.org/drawingml/2006/main">
             <a:off x="27993975" y="15363825"/>
-            <a:ext cx="13249275" cy="400050"/>
+            <a:ext cx="13249275" cy="314325"/>
           </a:xfrm>
           <a:prstGeom xmlns:a="http://schemas.openxmlformats.org/drawingml/2006/main" prst="rect">
             <a:avLst/>
@@ -4369,21 +4419,21 @@
       </p:sp>
       <p:sp>
         <p:nvSpPr>
-          <p:cNvPr id="73" name="figure-three-source">
-            <a:extLst xmlns:a="http://schemas.openxmlformats.org/drawingml/2006/main">
-              <a:ext uri="{FF2B5EF4-FFF2-40B4-BE49-F238E27FC236}">
-                <a16:creationId xmlns:a16="http://schemas.microsoft.com/office/drawing/2014/main" id="{8BA893C1-AD53-4795-961D-92215E9BC550}"/>
-              </a:ext>
-            </a:extLst>
-          </p:cNvPr>
-          <p:cNvSpPr>
-            <a:spLocks xmlns:a="http://schemas.openxmlformats.org/drawingml/2006/main" noGrp="1"/>
-          </p:cNvSpPr>
-          <p:nvPr/>
-        </p:nvSpPr>
-        <p:spPr>
-          <a:xfrm xmlns:a="http://schemas.openxmlformats.org/drawingml/2006/main">
-            <a:off x="27993975" y="15678150"/>
+          <p:cNvPr id="74" name="figure-three-source">
+            <a:extLst xmlns:a="http://schemas.openxmlformats.org/drawingml/2006/main">
+              <a:ext uri="{FF2B5EF4-FFF2-40B4-BE49-F238E27FC236}">
+                <a16:creationId xmlns:a16="http://schemas.microsoft.com/office/drawing/2014/main" id="{56975894-00F8-420B-8D6A-F7AF356980E4}"/>
+              </a:ext>
+            </a:extLst>
+          </p:cNvPr>
+          <p:cNvSpPr>
+            <a:spLocks xmlns:a="http://schemas.openxmlformats.org/drawingml/2006/main" noGrp="1"/>
+          </p:cNvSpPr>
+          <p:nvPr/>
+        </p:nvSpPr>
+        <p:spPr>
+          <a:xfrm xmlns:a="http://schemas.openxmlformats.org/drawingml/2006/main">
+            <a:off x="27993975" y="15687675"/>
             <a:ext cx="13249275" cy="361950"/>
           </a:xfrm>
           <a:prstGeom xmlns:a="http://schemas.openxmlformats.org/drawingml/2006/main" prst="rect">
@@ -4400,14 +4450,14 @@
           <a:lstStyle xmlns:a="http://schemas.openxmlformats.org/drawingml/2006/main"/>
           <a:p xmlns:a="http://schemas.openxmlformats.org/drawingml/2006/main">
             <a:pPr>
-              <a:defRPr sz="1875" i="1">
+              <a:defRPr sz="1875">
                 <a:solidFill>
                   <a:srgbClr val="2C8C99"/>
                 </a:solidFill>
               </a:defRPr>
             </a:pPr>
             <a:r>
-              <a:rPr sz="1875" i="1">
+              <a:rPr sz="1875">
                 <a:solidFill>
                   <a:srgbClr val="2C8C99"/>
                 </a:solidFill>
@@ -4419,10 +4469,10 @@
       </p:sp>
       <p:sp>
         <p:nvSpPr>
-          <p:cNvPr id="74" name="validation-visual-heading-title">
-            <a:extLst xmlns:a="http://schemas.openxmlformats.org/drawingml/2006/main">
-              <a:ext uri="{FF2B5EF4-FFF2-40B4-BE49-F238E27FC236}">
-                <a16:creationId xmlns:a16="http://schemas.microsoft.com/office/drawing/2014/main" id="{974B7BBA-9184-4F60-A682-1CD7B6FF7340}"/>
+          <p:cNvPr id="75" name="validation-visual-heading-title">
+            <a:extLst xmlns:a="http://schemas.openxmlformats.org/drawingml/2006/main">
+              <a:ext uri="{FF2B5EF4-FFF2-40B4-BE49-F238E27FC236}">
+                <a16:creationId xmlns:a16="http://schemas.microsoft.com/office/drawing/2014/main" id="{DE9AA71C-E3AF-4AC0-862A-D610F5BDB228}"/>
               </a:ext>
             </a:extLst>
           </p:cNvPr>
@@ -4469,10 +4519,10 @@
       </p:sp>
       <p:sp>
         <p:nvSpPr>
-          <p:cNvPr id="75" name="validation-visual-heading-rule">
-            <a:extLst xmlns:a="http://schemas.openxmlformats.org/drawingml/2006/main">
-              <a:ext uri="{FF2B5EF4-FFF2-40B4-BE49-F238E27FC236}">
-                <a16:creationId xmlns:a16="http://schemas.microsoft.com/office/drawing/2014/main" id="{E06A7DAD-DF93-466C-ACD7-0C3C4175F5FB}"/>
+          <p:cNvPr id="76" name="validation-visual-heading-rule">
+            <a:extLst xmlns:a="http://schemas.openxmlformats.org/drawingml/2006/main">
+              <a:ext uri="{FF2B5EF4-FFF2-40B4-BE49-F238E27FC236}">
+                <a16:creationId xmlns:a16="http://schemas.microsoft.com/office/drawing/2014/main" id="{D8C498F3-E80A-4F77-9437-5EE339C97416}"/>
               </a:ext>
             </a:extLst>
           </p:cNvPr>
@@ -4502,10 +4552,10 @@
       </p:sp>
       <p:sp>
         <p:nvSpPr>
-          <p:cNvPr id="76" name="figure-four-frame">
-            <a:extLst xmlns:a="http://schemas.openxmlformats.org/drawingml/2006/main">
-              <a:ext uri="{FF2B5EF4-FFF2-40B4-BE49-F238E27FC236}">
-                <a16:creationId xmlns:a16="http://schemas.microsoft.com/office/drawing/2014/main" id="{74C85410-D0C9-4729-B332-BA3C671B014E}"/>
+          <p:cNvPr id="77" name="figure-four-frame">
+            <a:extLst xmlns:a="http://schemas.openxmlformats.org/drawingml/2006/main">
+              <a:ext uri="{FF2B5EF4-FFF2-40B4-BE49-F238E27FC236}">
+                <a16:creationId xmlns:a16="http://schemas.microsoft.com/office/drawing/2014/main" id="{740A9886-1AA7-4867-8449-3059AB0F6C4C}"/>
               </a:ext>
             </a:extLst>
           </p:cNvPr>
@@ -4537,17 +4587,17 @@
       </p:sp>
       <p:pic>
         <p:nvPicPr>
-          <p:cNvPr id="164" name=""/>
+          <p:cNvPr id="167" name=""/>
           <p:cNvPicPr>
             <a:picLocks xmlns:a="http://schemas.openxmlformats.org/drawingml/2006/main" noChangeAspect="1"/>
           </p:cNvPicPr>
           <p:nvPr/>
         </p:nvPicPr>
         <p:blipFill>
-          <a:blip xmlns:r="http://schemas.openxmlformats.org/officeDocument/2006/relationships" xmlns:a="http://schemas.openxmlformats.org/drawingml/2006/main" r:embed="R783054ee9c6e475c">
+          <a:blip xmlns:r="http://schemas.openxmlformats.org/officeDocument/2006/relationships" xmlns:a="http://schemas.openxmlformats.org/drawingml/2006/main" r:embed="R97f04a6d2fd247a2">
             <a:extLst>
               <a:ext uri="{96DAC541-7B7A-43D3-8B79-37D633B846F1}">
-                <asvg:svgBlip xmlns:asvg="http://schemas.microsoft.com/office/drawing/2016/SVG/main" r:embed="R529c2d32ea754c98"/>
+                <asvg:svgBlip xmlns:asvg="http://schemas.microsoft.com/office/drawing/2016/SVG/main" r:embed="R86dfd18e29a94162"/>
               </a:ext>
             </a:extLst>
           </a:blip>
@@ -4565,10 +4615,10 @@
       </p:pic>
       <p:sp>
         <p:nvSpPr>
-          <p:cNvPr id="78" name="figure-four-caption">
-            <a:extLst xmlns:a="http://schemas.openxmlformats.org/drawingml/2006/main">
-              <a:ext uri="{FF2B5EF4-FFF2-40B4-BE49-F238E27FC236}">
-                <a16:creationId xmlns:a16="http://schemas.microsoft.com/office/drawing/2014/main" id="{08F3EBFB-B1CD-49EA-9921-1FDC45C03341}"/>
+          <p:cNvPr id="79" name="figure-four-caption">
+            <a:extLst xmlns:a="http://schemas.openxmlformats.org/drawingml/2006/main">
+              <a:ext uri="{FF2B5EF4-FFF2-40B4-BE49-F238E27FC236}">
+                <a16:creationId xmlns:a16="http://schemas.microsoft.com/office/drawing/2014/main" id="{5407ACC7-0B71-44A3-AA6D-244978541274}"/>
               </a:ext>
             </a:extLst>
           </p:cNvPr>
@@ -4580,7 +4630,7 @@
         <p:spPr>
           <a:xfrm xmlns:a="http://schemas.openxmlformats.org/drawingml/2006/main">
             <a:off x="27993975" y="23841075"/>
-            <a:ext cx="13249275" cy="400050"/>
+            <a:ext cx="13249275" cy="314325"/>
           </a:xfrm>
           <a:prstGeom xmlns:a="http://schemas.openxmlformats.org/drawingml/2006/main" prst="rect">
             <a:avLst/>
@@ -4615,21 +4665,21 @@
       </p:sp>
       <p:sp>
         <p:nvSpPr>
-          <p:cNvPr id="79" name="figure-four-source">
-            <a:extLst xmlns:a="http://schemas.openxmlformats.org/drawingml/2006/main">
-              <a:ext uri="{FF2B5EF4-FFF2-40B4-BE49-F238E27FC236}">
-                <a16:creationId xmlns:a16="http://schemas.microsoft.com/office/drawing/2014/main" id="{7C8DACDE-44AF-49E6-AC42-4FCE82BC7EF0}"/>
-              </a:ext>
-            </a:extLst>
-          </p:cNvPr>
-          <p:cNvSpPr>
-            <a:spLocks xmlns:a="http://schemas.openxmlformats.org/drawingml/2006/main" noGrp="1"/>
-          </p:cNvSpPr>
-          <p:nvPr/>
-        </p:nvSpPr>
-        <p:spPr>
-          <a:xfrm xmlns:a="http://schemas.openxmlformats.org/drawingml/2006/main">
-            <a:off x="27993975" y="24155400"/>
+          <p:cNvPr id="80" name="figure-four-source">
+            <a:extLst xmlns:a="http://schemas.openxmlformats.org/drawingml/2006/main">
+              <a:ext uri="{FF2B5EF4-FFF2-40B4-BE49-F238E27FC236}">
+                <a16:creationId xmlns:a16="http://schemas.microsoft.com/office/drawing/2014/main" id="{14AC0FBD-EDAF-47DC-A4E8-F9A55BC26A80}"/>
+              </a:ext>
+            </a:extLst>
+          </p:cNvPr>
+          <p:cNvSpPr>
+            <a:spLocks xmlns:a="http://schemas.openxmlformats.org/drawingml/2006/main" noGrp="1"/>
+          </p:cNvSpPr>
+          <p:nvPr/>
+        </p:nvSpPr>
+        <p:spPr>
+          <a:xfrm xmlns:a="http://schemas.openxmlformats.org/drawingml/2006/main">
+            <a:off x="27993975" y="24164925"/>
             <a:ext cx="13249275" cy="361950"/>
           </a:xfrm>
           <a:prstGeom xmlns:a="http://schemas.openxmlformats.org/drawingml/2006/main" prst="rect">
@@ -4646,14 +4696,14 @@
           <a:lstStyle xmlns:a="http://schemas.openxmlformats.org/drawingml/2006/main"/>
           <a:p xmlns:a="http://schemas.openxmlformats.org/drawingml/2006/main">
             <a:pPr>
-              <a:defRPr sz="1875" i="1">
+              <a:defRPr sz="1875">
                 <a:solidFill>
                   <a:srgbClr val="2C8C99"/>
                 </a:solidFill>
               </a:defRPr>
             </a:pPr>
             <a:r>
-              <a:rPr sz="1875" i="1">
+              <a:rPr sz="1875">
                 <a:solidFill>
                   <a:srgbClr val="2C8C99"/>
                 </a:solidFill>
@@ -4665,10 +4715,10 @@
       </p:sp>
       <p:sp>
         <p:nvSpPr>
-          <p:cNvPr id="80" name="conclusion-heading-title">
-            <a:extLst xmlns:a="http://schemas.openxmlformats.org/drawingml/2006/main">
-              <a:ext uri="{FF2B5EF4-FFF2-40B4-BE49-F238E27FC236}">
-                <a16:creationId xmlns:a16="http://schemas.microsoft.com/office/drawing/2014/main" id="{702970AD-E065-45F7-85CF-1840B1D3A458}"/>
+          <p:cNvPr id="81" name="conclusion-heading-title">
+            <a:extLst xmlns:a="http://schemas.openxmlformats.org/drawingml/2006/main">
+              <a:ext uri="{FF2B5EF4-FFF2-40B4-BE49-F238E27FC236}">
+                <a16:creationId xmlns:a16="http://schemas.microsoft.com/office/drawing/2014/main" id="{4F519B1D-C5DE-4AD2-83D9-DD7B2887AB7F}"/>
               </a:ext>
             </a:extLst>
           </p:cNvPr>
@@ -4715,10 +4765,10 @@
       </p:sp>
       <p:sp>
         <p:nvSpPr>
-          <p:cNvPr id="81" name="conclusion-heading-rule">
-            <a:extLst xmlns:a="http://schemas.openxmlformats.org/drawingml/2006/main">
-              <a:ext uri="{FF2B5EF4-FFF2-40B4-BE49-F238E27FC236}">
-                <a16:creationId xmlns:a16="http://schemas.microsoft.com/office/drawing/2014/main" id="{031D8E3B-F7A6-4ACE-A173-05CBB0482371}"/>
+          <p:cNvPr id="82" name="conclusion-heading-rule">
+            <a:extLst xmlns:a="http://schemas.openxmlformats.org/drawingml/2006/main">
+              <a:ext uri="{FF2B5EF4-FFF2-40B4-BE49-F238E27FC236}">
+                <a16:creationId xmlns:a16="http://schemas.microsoft.com/office/drawing/2014/main" id="{0D3077AC-A8CF-42F9-B9F2-BEBF07402B6F}"/>
               </a:ext>
             </a:extLst>
           </p:cNvPr>
@@ -4748,10 +4798,10 @@
       </p:sp>
       <p:sp>
         <p:nvSpPr>
-          <p:cNvPr id="82" name="conclusion-panel">
-            <a:extLst xmlns:a="http://schemas.openxmlformats.org/drawingml/2006/main">
-              <a:ext uri="{FF2B5EF4-FFF2-40B4-BE49-F238E27FC236}">
-                <a16:creationId xmlns:a16="http://schemas.microsoft.com/office/drawing/2014/main" id="{50F4BA34-3F55-4D2E-A389-A72B367C9B2C}"/>
+          <p:cNvPr id="83" name="conclusion-panel">
+            <a:extLst xmlns:a="http://schemas.openxmlformats.org/drawingml/2006/main">
+              <a:ext uri="{FF2B5EF4-FFF2-40B4-BE49-F238E27FC236}">
+                <a16:creationId xmlns:a16="http://schemas.microsoft.com/office/drawing/2014/main" id="{0099CF81-2ACC-49E0-BF28-47168D08760A}"/>
               </a:ext>
             </a:extLst>
           </p:cNvPr>
@@ -4783,10 +4833,10 @@
       </p:sp>
       <p:sp>
         <p:nvSpPr>
-          <p:cNvPr id="83" name="conclusion">
-            <a:extLst xmlns:a="http://schemas.openxmlformats.org/drawingml/2006/main">
-              <a:ext uri="{FF2B5EF4-FFF2-40B4-BE49-F238E27FC236}">
-                <a16:creationId xmlns:a16="http://schemas.microsoft.com/office/drawing/2014/main" id="{DA7BB850-25A8-4FA9-A5B0-7D1F40EDFDE0}"/>
+          <p:cNvPr id="84" name="conclusion-lead">
+            <a:extLst xmlns:a="http://schemas.openxmlformats.org/drawingml/2006/main">
+              <a:ext uri="{FF2B5EF4-FFF2-40B4-BE49-F238E27FC236}">
+                <a16:creationId xmlns:a16="http://schemas.microsoft.com/office/drawing/2014/main" id="{9542EB96-E5A5-492C-936B-B238B802C723}"/>
               </a:ext>
             </a:extLst>
           </p:cNvPr>
@@ -4798,7 +4848,57 @@
         <p:spPr>
           <a:xfrm xmlns:a="http://schemas.openxmlformats.org/drawingml/2006/main">
             <a:off x="28089225" y="26174700"/>
-            <a:ext cx="13058775" cy="2190750"/>
+            <a:ext cx="13058775" cy="609600"/>
+          </a:xfrm>
+          <a:prstGeom xmlns:a="http://schemas.openxmlformats.org/drawingml/2006/main" prst="rect">
+            <a:avLst/>
+          </a:prstGeom>
+          <a:noFill xmlns:a="http://schemas.openxmlformats.org/drawingml/2006/main"/>
+          <a:ln xmlns:a="http://schemas.openxmlformats.org/drawingml/2006/main" w="0">
+            <a:noFill/>
+            <a:prstDash val="solid"/>
+          </a:ln>
+        </p:spPr>
+        <p:txBody>
+          <a:bodyPr xmlns:a="http://schemas.openxmlformats.org/drawingml/2006/main"/>
+          <a:lstStyle xmlns:a="http://schemas.openxmlformats.org/drawingml/2006/main"/>
+          <a:p xmlns:a="http://schemas.openxmlformats.org/drawingml/2006/main">
+            <a:pPr>
+              <a:defRPr sz="3000" b="1">
+                <a:solidFill>
+                  <a:srgbClr val="102A43"/>
+                </a:solidFill>
+              </a:defRPr>
+            </a:pPr>
+            <a:r>
+              <a:rPr sz="3000" b="1">
+                <a:solidFill>
+                  <a:srgbClr val="102A43"/>
+                </a:solidFill>
+              </a:rPr>
+              <a:t>A rights-safe methodological test fixture</a:t>
+            </a:r>
+          </a:p>
+        </p:txBody>
+      </p:sp>
+      <p:sp>
+        <p:nvSpPr>
+          <p:cNvPr id="85" name="conclusion">
+            <a:extLst xmlns:a="http://schemas.openxmlformats.org/drawingml/2006/main">
+              <a:ext uri="{FF2B5EF4-FFF2-40B4-BE49-F238E27FC236}">
+                <a16:creationId xmlns:a16="http://schemas.microsoft.com/office/drawing/2014/main" id="{4726B646-40F6-4782-A06D-46D73EADC355}"/>
+              </a:ext>
+            </a:extLst>
+          </p:cNvPr>
+          <p:cNvSpPr>
+            <a:spLocks xmlns:a="http://schemas.openxmlformats.org/drawingml/2006/main" noGrp="1"/>
+          </p:cNvSpPr>
+          <p:nvPr/>
+        </p:nvSpPr>
+        <p:spPr>
+          <a:xfrm xmlns:a="http://schemas.openxmlformats.org/drawingml/2006/main">
+            <a:off x="28089225" y="26860500"/>
+            <a:ext cx="13058775" cy="1504950"/>
           </a:xfrm>
           <a:prstGeom xmlns:a="http://schemas.openxmlformats.org/drawingml/2006/main" prst="rect">
             <a:avLst/>
@@ -4826,17 +4926,34 @@
                   <a:srgbClr val="102A43"/>
                 </a:solidFill>
               </a:rPr>
-              <a:t>AURORA-12 is a controlled, rights-safe fixture for testing evidence-linked scientific communication. It supports no inference about real biology, prognosis, treatment or clinical utility. Every number, cohort, feature, author and institution is fictional.</a:t>
-            </a:r>
-          </a:p>
-        </p:txBody>
-      </p:sp>
-      <p:sp>
-        <p:nvSpPr>
-          <p:cNvPr id="84" name="conclusion-evidence">
-            <a:extLst xmlns:a="http://schemas.openxmlformats.org/drawingml/2006/main">
-              <a:ext uri="{FF2B5EF4-FFF2-40B4-BE49-F238E27FC236}">
-                <a16:creationId xmlns:a16="http://schemas.microsoft.com/office/drawing/2014/main" id="{622A09C5-2272-4F48-8B6B-DDD1BFA16774}"/>
+              <a:t>• No biological, prognostic or clinical inference</a:t>
+            </a:r>
+          </a:p>
+          <a:p xmlns:a="http://schemas.openxmlformats.org/drawingml/2006/main">
+            <a:pPr>
+              <a:defRPr sz="2850">
+                <a:solidFill>
+                  <a:srgbClr val="102A43"/>
+                </a:solidFill>
+              </a:defRPr>
+            </a:pPr>
+            <a:r>
+              <a:rPr sz="2850">
+                <a:solidFill>
+                  <a:srgbClr val="102A43"/>
+                </a:solidFill>
+              </a:rPr>
+              <a:t>• All cohorts, values and identities are fictional</a:t>
+            </a:r>
+          </a:p>
+        </p:txBody>
+      </p:sp>
+      <p:sp>
+        <p:nvSpPr>
+          <p:cNvPr id="86" name="conclusion-evidence">
+            <a:extLst xmlns:a="http://schemas.openxmlformats.org/drawingml/2006/main">
+              <a:ext uri="{FF2B5EF4-FFF2-40B4-BE49-F238E27FC236}">
+                <a16:creationId xmlns:a16="http://schemas.microsoft.com/office/drawing/2014/main" id="{C82ED272-DC16-4300-853E-809D0491FC3A}"/>
               </a:ext>
             </a:extLst>
           </p:cNvPr>
@@ -4864,14 +4981,14 @@
           <a:lstStyle xmlns:a="http://schemas.openxmlformats.org/drawingml/2006/main"/>
           <a:p xmlns:a="http://schemas.openxmlformats.org/drawingml/2006/main">
             <a:pPr>
-              <a:defRPr sz="1875" i="1">
+              <a:defRPr sz="1875">
                 <a:solidFill>
                   <a:srgbClr val="2C8C99"/>
                 </a:solidFill>
               </a:defRPr>
             </a:pPr>
             <a:r>
-              <a:rPr sz="1875" i="1">
+              <a:rPr sz="1875">
                 <a:solidFill>
                   <a:srgbClr val="2C8C99"/>
                 </a:solidFill>
@@ -4883,10 +5000,10 @@
       </p:sp>
       <p:sp>
         <p:nvSpPr>
-          <p:cNvPr id="85" name="footer-band">
-            <a:extLst xmlns:a="http://schemas.openxmlformats.org/drawingml/2006/main">
-              <a:ext uri="{FF2B5EF4-FFF2-40B4-BE49-F238E27FC236}">
-                <a16:creationId xmlns:a16="http://schemas.microsoft.com/office/drawing/2014/main" id="{1472C739-3EF3-47E8-8A0E-C6607FC80CA1}"/>
+          <p:cNvPr id="87" name="footer-band">
+            <a:extLst xmlns:a="http://schemas.openxmlformats.org/drawingml/2006/main">
+              <a:ext uri="{FF2B5EF4-FFF2-40B4-BE49-F238E27FC236}">
+                <a16:creationId xmlns:a16="http://schemas.microsoft.com/office/drawing/2014/main" id="{D5C7C319-4C84-41C9-86F0-A9F5DBBC292E}"/>
               </a:ext>
             </a:extLst>
           </p:cNvPr>
@@ -4916,10 +5033,10 @@
       </p:sp>
       <p:sp>
         <p:nvSpPr>
-          <p:cNvPr id="86" name="footer-source">
-            <a:extLst xmlns:a="http://schemas.openxmlformats.org/drawingml/2006/main">
-              <a:ext uri="{FF2B5EF4-FFF2-40B4-BE49-F238E27FC236}">
-                <a16:creationId xmlns:a16="http://schemas.microsoft.com/office/drawing/2014/main" id="{4DAE6FC0-7E5A-4A5D-AD23-9CC74B0B92EA}"/>
+          <p:cNvPr id="88" name="footer-source">
+            <a:extLst xmlns:a="http://schemas.openxmlformats.org/drawingml/2006/main">
+              <a:ext uri="{FF2B5EF4-FFF2-40B4-BE49-F238E27FC236}">
+                <a16:creationId xmlns:a16="http://schemas.microsoft.com/office/drawing/2014/main" id="{2C78F404-3D9D-4AD9-A86A-400BAB6B7A05}"/>
               </a:ext>
             </a:extLst>
           </p:cNvPr>
@@ -4931,7 +5048,7 @@
         <p:spPr>
           <a:xfrm xmlns:a="http://schemas.openxmlformats.org/drawingml/2006/main">
             <a:off x="1333500" y="29594175"/>
-            <a:ext cx="28575000" cy="400050"/>
+            <a:ext cx="28194000" cy="400050"/>
           </a:xfrm>
           <a:prstGeom xmlns:a="http://schemas.openxmlformats.org/drawingml/2006/main" prst="rect">
             <a:avLst/>
@@ -4966,10 +5083,10 @@
       </p:sp>
       <p:sp>
         <p:nvSpPr>
-          <p:cNvPr id="87" name="footer-status">
-            <a:extLst xmlns:a="http://schemas.openxmlformats.org/drawingml/2006/main">
-              <a:ext uri="{FF2B5EF4-FFF2-40B4-BE49-F238E27FC236}">
-                <a16:creationId xmlns:a16="http://schemas.microsoft.com/office/drawing/2014/main" id="{A677E8B7-0BB0-45F3-838D-2C5DB5224950}"/>
+          <p:cNvPr id="89" name="footer-status">
+            <a:extLst xmlns:a="http://schemas.openxmlformats.org/drawingml/2006/main">
+              <a:ext uri="{FF2B5EF4-FFF2-40B4-BE49-F238E27FC236}">
+                <a16:creationId xmlns:a16="http://schemas.microsoft.com/office/drawing/2014/main" id="{B0843F78-E042-485B-A65C-4660706F0A6A}"/>
               </a:ext>
             </a:extLst>
           </p:cNvPr>
@@ -5017,7 +5134,7 @@
     </p:spTree>
     <p:extLst>
       <p:ext uri="{BB962C8B-B14F-4D97-AF65-F5344CB8AC3E}">
-        <p14:creationId xmlns:p14="http://schemas.microsoft.com/office/powerpoint/2010/main" val="1129746968"/>
+        <p14:creationId xmlns:p14="http://schemas.microsoft.com/office/powerpoint/2010/main" val="1262956495"/>
       </p:ext>
     </p:extLst>
   </p:cSld>

</xml_diff>